<commit_message>
docs: update pitch deck v2 with verified ops stats
</commit_message>
<xml_diff>
--- a/Rift_L1_Pitch.pptx
+++ b/Rift_L1_Pitch.pptx
@@ -179,8 +179,8 @@
                 <c:ptCount val="5"/>
                 <c:lvl>
                   <c:pt idx="0">
-                    <c:v>GitHub
-Runner</c:v>
+                    <c:v>GitHub CI
+(2 threads)</c:v>
                   </c:pt>
                   <c:pt idx="1">
                     <c:v>Intel i7
@@ -1877,15 +1877,15 @@
         </p:nvSpPr>
         <p:spPr>
           <a:xfrm>
-            <a:off x="8961120" y="1097280"/>
-            <a:ext cx="2377440" cy="2377440"/>
+            <a:off x="8961120" y="914400"/>
+            <a:ext cx="2743200" cy="2743200"/>
           </a:xfrm>
           <a:prstGeom prst="ellipse">
             <a:avLst/>
           </a:prstGeom>
           <a:solidFill>
             <a:srgbClr val="7C3AED">
-              <a:alpha val="40000"/>
+              <a:alpha val="35000"/>
             </a:srgbClr>
           </a:solidFill>
           <a:ln w="25400">
@@ -1904,8 +1904,8 @@
         </p:nvSpPr>
         <p:spPr>
           <a:xfrm>
-            <a:off x="8961120" y="1371600"/>
-            <a:ext cx="2377440" cy="1828800"/>
+            <a:off x="8961120" y="1188720"/>
+            <a:ext cx="2743200" cy="2011680"/>
           </a:xfrm>
           <a:prstGeom prst="rect">
             <a:avLst/>
@@ -1921,14 +1921,17 @@
               <a:buNone/>
             </a:pPr>
             <a:r>
-              <a:rPr lang="en-US" sz="6400" dirty="0">
-                <a:solidFill>
-                  <a:srgbClr val="000000"/>
-                </a:solidFill>
+              <a:rPr lang="en-US" sz="7200" dirty="0">
+                <a:solidFill>
+                  <a:srgbClr val="FFFFFF"/>
+                </a:solidFill>
+                <a:latin typeface="Arial" pitchFamily="34" charset="0"/>
+                <a:ea typeface="Arial" pitchFamily="34" charset="-122"/>
+                <a:cs typeface="Arial" pitchFamily="34" charset="-120"/>
               </a:rPr>
               <a:t>⚡</a:t>
             </a:r>
-            <a:endParaRPr lang="en-US" sz="6400" dirty="0"/>
+            <a:endParaRPr lang="en-US" sz="7200" dirty="0"/>
           </a:p>
         </p:txBody>
       </p:sp>
@@ -1940,8 +1943,8 @@
         </p:nvSpPr>
         <p:spPr>
           <a:xfrm>
-            <a:off x="457200" y="1280160"/>
-            <a:ext cx="8229600" cy="1097280"/>
+            <a:off x="457200" y="1188720"/>
+            <a:ext cx="8229600" cy="1005840"/>
           </a:xfrm>
           <a:prstGeom prst="rect">
             <a:avLst/>
@@ -1979,8 +1982,8 @@
         </p:nvSpPr>
         <p:spPr>
           <a:xfrm>
-            <a:off x="457200" y="2423160"/>
-            <a:ext cx="7315200" cy="502920"/>
+            <a:off x="457200" y="2286000"/>
+            <a:ext cx="7315200" cy="548640"/>
           </a:xfrm>
           <a:prstGeom prst="rect">
             <a:avLst/>
@@ -2018,7 +2021,7 @@
         </p:nvSpPr>
         <p:spPr>
           <a:xfrm>
-            <a:off x="457200" y="2971800"/>
+            <a:off x="457200" y="2880360"/>
             <a:ext cx="7772400" cy="411480"/>
           </a:xfrm>
           <a:prstGeom prst="rect">
@@ -2035,7 +2038,7 @@
               <a:buNone/>
             </a:pPr>
             <a:r>
-              <a:rPr lang="en-US" sz="1600" dirty="0">
+              <a:rPr lang="en-US" sz="1500" dirty="0">
                 <a:solidFill>
                   <a:srgbClr val="A0AEC0"/>
                 </a:solidFill>
@@ -2045,7 +2048,7 @@
               </a:rPr>
               <a:t>Deterministic · O(1) Distribution · Zero Invariant Violations</a:t>
             </a:r>
-            <a:endParaRPr lang="en-US" sz="1600" dirty="0"/>
+            <a:endParaRPr lang="en-US" sz="1500" dirty="0"/>
           </a:p>
         </p:txBody>
       </p:sp>
@@ -2057,7 +2060,7 @@
         </p:nvSpPr>
         <p:spPr>
           <a:xfrm>
-            <a:off x="457200" y="3520440"/>
+            <a:off x="457200" y="3429000"/>
             <a:ext cx="5486400" cy="27432"/>
           </a:xfrm>
           <a:prstGeom prst="rect">
@@ -2082,24 +2085,24 @@
         </p:nvSpPr>
         <p:spPr>
           <a:xfrm>
-            <a:off x="457200" y="3749040"/>
-            <a:ext cx="2560320" cy="502920"/>
-          </a:xfrm>
-          <a:prstGeom prst="rect">
-            <a:avLst/>
-          </a:prstGeom>
-          <a:noFill/>
-          <a:ln/>
-        </p:spPr>
-        <p:txBody>
-          <a:bodyPr wrap="square" rtlCol="0" anchor="ctr"/>
-          <a:lstStyle/>
-          <a:p>
-            <a:pPr indent="0" marL="0">
-              <a:buNone/>
-            </a:pPr>
-            <a:r>
-              <a:rPr lang="en-US" sz="2600" b="1" dirty="0">
+            <a:off x="457200" y="3657600"/>
+            <a:ext cx="2651760" cy="548640"/>
+          </a:xfrm>
+          <a:prstGeom prst="rect">
+            <a:avLst/>
+          </a:prstGeom>
+          <a:noFill/>
+          <a:ln/>
+        </p:spPr>
+        <p:txBody>
+          <a:bodyPr wrap="square" rtlCol="0" anchor="ctr"/>
+          <a:lstStyle/>
+          <a:p>
+            <a:pPr indent="0" marL="0">
+              <a:buNone/>
+            </a:pPr>
+            <a:r>
+              <a:rPr lang="en-US" sz="2800" b="1" dirty="0">
                 <a:solidFill>
                   <a:srgbClr val="00D4FF"/>
                 </a:solidFill>
@@ -2107,9 +2110,9 @@
                 <a:ea typeface="Arial" pitchFamily="34" charset="-122"/>
                 <a:cs typeface="Arial" pitchFamily="34" charset="-120"/>
               </a:rPr>
-              <a:t>256M+</a:t>
-            </a:r>
-            <a:endParaRPr lang="en-US" sz="2600" dirty="0"/>
+              <a:t>122B+</a:t>
+            </a:r>
+            <a:endParaRPr lang="en-US" sz="2800" dirty="0"/>
           </a:p>
         </p:txBody>
       </p:sp>
@@ -2121,8 +2124,8 @@
         </p:nvSpPr>
         <p:spPr>
           <a:xfrm>
-            <a:off x="457200" y="4251960"/>
-            <a:ext cx="2560320" cy="320040"/>
+            <a:off x="457200" y="4206240"/>
+            <a:ext cx="2651760" cy="320040"/>
           </a:xfrm>
           <a:prstGeom prst="rect">
             <a:avLst/>
@@ -2146,7 +2149,7 @@
                 <a:ea typeface="Arial" pitchFamily="34" charset="-122"/>
                 <a:cs typeface="Arial" pitchFamily="34" charset="-120"/>
               </a:rPr>
-              <a:t>Ops Tested</a:t>
+              <a:t>Ops per run</a:t>
             </a:r>
             <a:endParaRPr lang="en-US" sz="1300" dirty="0"/>
           </a:p>
@@ -2160,24 +2163,24 @@
         </p:nvSpPr>
         <p:spPr>
           <a:xfrm>
-            <a:off x="3200400" y="3749040"/>
-            <a:ext cx="2560320" cy="502920"/>
-          </a:xfrm>
-          <a:prstGeom prst="rect">
-            <a:avLst/>
-          </a:prstGeom>
-          <a:noFill/>
-          <a:ln/>
-        </p:spPr>
-        <p:txBody>
-          <a:bodyPr wrap="square" rtlCol="0" anchor="ctr"/>
-          <a:lstStyle/>
-          <a:p>
-            <a:pPr indent="0" marL="0">
-              <a:buNone/>
-            </a:pPr>
-            <a:r>
-              <a:rPr lang="en-US" sz="2600" b="1" dirty="0">
+            <a:off x="3291840" y="3657600"/>
+            <a:ext cx="2651760" cy="548640"/>
+          </a:xfrm>
+          <a:prstGeom prst="rect">
+            <a:avLst/>
+          </a:prstGeom>
+          <a:noFill/>
+          <a:ln/>
+        </p:spPr>
+        <p:txBody>
+          <a:bodyPr wrap="square" rtlCol="0" anchor="ctr"/>
+          <a:lstStyle/>
+          <a:p>
+            <a:pPr indent="0" marL="0">
+              <a:buNone/>
+            </a:pPr>
+            <a:r>
+              <a:rPr lang="en-US" sz="2800" b="1" dirty="0">
                 <a:solidFill>
                   <a:srgbClr val="00D4FF"/>
                 </a:solidFill>
@@ -2187,7 +2190,7 @@
               </a:rPr>
               <a:t>0</a:t>
             </a:r>
-            <a:endParaRPr lang="en-US" sz="2600" dirty="0"/>
+            <a:endParaRPr lang="en-US" sz="2800" dirty="0"/>
           </a:p>
         </p:txBody>
       </p:sp>
@@ -2199,8 +2202,8 @@
         </p:nvSpPr>
         <p:spPr>
           <a:xfrm>
-            <a:off x="3200400" y="4251960"/>
-            <a:ext cx="2560320" cy="320040"/>
+            <a:off x="3291840" y="4206240"/>
+            <a:ext cx="2651760" cy="320040"/>
           </a:xfrm>
           <a:prstGeom prst="rect">
             <a:avLst/>
@@ -2224,7 +2227,7 @@
                 <a:ea typeface="Arial" pitchFamily="34" charset="-122"/>
                 <a:cs typeface="Arial" pitchFamily="34" charset="-120"/>
               </a:rPr>
-              <a:t>Crashes</a:t>
+              <a:t>Violations</a:t>
             </a:r>
             <a:endParaRPr lang="en-US" sz="1300" dirty="0"/>
           </a:p>
@@ -2238,24 +2241,24 @@
         </p:nvSpPr>
         <p:spPr>
           <a:xfrm>
-            <a:off x="5943600" y="3749040"/>
-            <a:ext cx="2560320" cy="502920"/>
-          </a:xfrm>
-          <a:prstGeom prst="rect">
-            <a:avLst/>
-          </a:prstGeom>
-          <a:noFill/>
-          <a:ln/>
-        </p:spPr>
-        <p:txBody>
-          <a:bodyPr wrap="square" rtlCol="0" anchor="ctr"/>
-          <a:lstStyle/>
-          <a:p>
-            <a:pPr indent="0" marL="0">
-              <a:buNone/>
-            </a:pPr>
-            <a:r>
-              <a:rPr lang="en-US" sz="2600" b="1" dirty="0">
+            <a:off x="6126480" y="3657600"/>
+            <a:ext cx="2651760" cy="548640"/>
+          </a:xfrm>
+          <a:prstGeom prst="rect">
+            <a:avLst/>
+          </a:prstGeom>
+          <a:noFill/>
+          <a:ln/>
+        </p:spPr>
+        <p:txBody>
+          <a:bodyPr wrap="square" rtlCol="0" anchor="ctr"/>
+          <a:lstStyle/>
+          <a:p>
+            <a:pPr indent="0" marL="0">
+              <a:buNone/>
+            </a:pPr>
+            <a:r>
+              <a:rPr lang="en-US" sz="2800" b="1" dirty="0">
                 <a:solidFill>
                   <a:srgbClr val="00D4FF"/>
                 </a:solidFill>
@@ -2265,7 +2268,7 @@
               </a:rPr>
               <a:t>5h 55m</a:t>
             </a:r>
-            <a:endParaRPr lang="en-US" sz="2600" dirty="0"/>
+            <a:endParaRPr lang="en-US" sz="2800" dirty="0"/>
           </a:p>
         </p:txBody>
       </p:sp>
@@ -2277,8 +2280,8 @@
         </p:nvSpPr>
         <p:spPr>
           <a:xfrm>
-            <a:off x="5943600" y="4251960"/>
-            <a:ext cx="2560320" cy="320040"/>
+            <a:off x="6126480" y="4206240"/>
+            <a:ext cx="2651760" cy="320040"/>
           </a:xfrm>
           <a:prstGeom prst="rect">
             <a:avLst/>
@@ -2302,7 +2305,7 @@
                 <a:ea typeface="Arial" pitchFamily="34" charset="-122"/>
                 <a:cs typeface="Arial" pitchFamily="34" charset="-120"/>
               </a:rPr>
-              <a:t>Fuzz Duration</a:t>
+              <a:t>Per CI run</a:t>
             </a:r>
             <a:endParaRPr lang="en-US" sz="1300" dirty="0"/>
           </a:p>
@@ -2316,24 +2319,24 @@
         </p:nvSpPr>
         <p:spPr>
           <a:xfrm>
-            <a:off x="8686800" y="3749040"/>
-            <a:ext cx="2560320" cy="502920"/>
-          </a:xfrm>
-          <a:prstGeom prst="rect">
-            <a:avLst/>
-          </a:prstGeom>
-          <a:noFill/>
-          <a:ln/>
-        </p:spPr>
-        <p:txBody>
-          <a:bodyPr wrap="square" rtlCol="0" anchor="ctr"/>
-          <a:lstStyle/>
-          <a:p>
-            <a:pPr indent="0" marL="0">
-              <a:buNone/>
-            </a:pPr>
-            <a:r>
-              <a:rPr lang="en-US" sz="2600" b="1" dirty="0">
+            <a:off x="8961120" y="3657600"/>
+            <a:ext cx="2651760" cy="548640"/>
+          </a:xfrm>
+          <a:prstGeom prst="rect">
+            <a:avLst/>
+          </a:prstGeom>
+          <a:noFill/>
+          <a:ln/>
+        </p:spPr>
+        <p:txBody>
+          <a:bodyPr wrap="square" rtlCol="0" anchor="ctr"/>
+          <a:lstStyle/>
+          <a:p>
+            <a:pPr indent="0" marL="0">
+              <a:buNone/>
+            </a:pPr>
+            <a:r>
+              <a:rPr lang="en-US" sz="2800" b="1" dirty="0">
                 <a:solidFill>
                   <a:srgbClr val="00D4FF"/>
                 </a:solidFill>
@@ -2343,7 +2346,7 @@
               </a:rPr>
               <a:t>~5.75M</a:t>
             </a:r>
-            <a:endParaRPr lang="en-US" sz="2600" dirty="0"/>
+            <a:endParaRPr lang="en-US" sz="2800" dirty="0"/>
           </a:p>
         </p:txBody>
       </p:sp>
@@ -2355,8 +2358,8 @@
         </p:nvSpPr>
         <p:spPr>
           <a:xfrm>
-            <a:off x="8686800" y="4251960"/>
-            <a:ext cx="2560320" cy="320040"/>
+            <a:off x="8961120" y="4206240"/>
+            <a:ext cx="2651760" cy="320040"/>
           </a:xfrm>
           <a:prstGeom prst="rect">
             <a:avLst/>
@@ -2380,7 +2383,7 @@
                 <a:ea typeface="Arial" pitchFamily="34" charset="-122"/>
                 <a:cs typeface="Arial" pitchFamily="34" charset="-120"/>
               </a:rPr>
-              <a:t>Ops/sec (CI)</a:t>
+              <a:t>Ops/sec CI</a:t>
             </a:r>
             <a:endParaRPr lang="en-US" sz="1300" dirty="0"/>
           </a:p>
@@ -2394,7 +2397,46 @@
         </p:nvSpPr>
         <p:spPr>
           <a:xfrm>
-            <a:off x="457200" y="6126480"/>
+            <a:off x="457200" y="4846320"/>
+            <a:ext cx="10972800" cy="365760"/>
+          </a:xfrm>
+          <a:prstGeom prst="rect">
+            <a:avLst/>
+          </a:prstGeom>
+          <a:noFill/>
+          <a:ln/>
+        </p:spPr>
+        <p:txBody>
+          <a:bodyPr wrap="square" rtlCol="0" anchor="ctr"/>
+          <a:lstStyle/>
+          <a:p>
+            <a:pPr indent="0" marL="0">
+              <a:buNone/>
+            </a:pPr>
+            <a:r>
+              <a:rPr lang="en-US" sz="1300" dirty="0">
+                <a:solidFill>
+                  <a:srgbClr val="10B981"/>
+                </a:solidFill>
+                <a:latin typeface="Arial" pitchFamily="34" charset="0"/>
+                <a:ea typeface="Arial" pitchFamily="34" charset="-122"/>
+                <a:cs typeface="Arial" pitchFamily="34" charset="-120"/>
+              </a:rPr>
+              <a:t>Multiple parallel CI runs · Cumulative ops in the trillions · Zero crashes across all runs</a:t>
+            </a:r>
+            <a:endParaRPr lang="en-US" sz="1300" dirty="0"/>
+          </a:p>
+        </p:txBody>
+      </p:sp>
+      <p:sp>
+        <p:nvSpPr>
+          <p:cNvPr id="18" name="Text 16"/>
+          <p:cNvSpPr/>
+          <p:nvPr/>
+        </p:nvSpPr>
+        <p:spPr>
+          <a:xfrm>
+            <a:off x="457200" y="6217920"/>
             <a:ext cx="9144000" cy="320040"/>
           </a:xfrm>
           <a:prstGeom prst="rect">
@@ -2465,7 +2507,7 @@
         </p:nvSpPr>
         <p:spPr>
           <a:xfrm>
-            <a:off x="457200" y="365760"/>
+            <a:off x="457200" y="320040"/>
             <a:ext cx="11247120" cy="640080"/>
           </a:xfrm>
           <a:prstGeom prst="rect">
@@ -2504,8 +2546,8 @@
         </p:nvSpPr>
         <p:spPr>
           <a:xfrm>
-            <a:off x="457200" y="1280160"/>
-            <a:ext cx="3566160" cy="4389120"/>
+            <a:off x="457200" y="1188720"/>
+            <a:ext cx="3657600" cy="4572000"/>
           </a:xfrm>
           <a:prstGeom prst="rect">
             <a:avLst/>
@@ -2529,8 +2571,8 @@
         </p:nvSpPr>
         <p:spPr>
           <a:xfrm>
-            <a:off x="457200" y="1463040"/>
-            <a:ext cx="3566160" cy="640080"/>
+            <a:off x="457200" y="1371600"/>
+            <a:ext cx="3657600" cy="640080"/>
           </a:xfrm>
           <a:prstGeom prst="rect">
             <a:avLst/>
@@ -2548,8 +2590,11 @@
             <a:r>
               <a:rPr lang="en-US" sz="3200" dirty="0">
                 <a:solidFill>
-                  <a:srgbClr val="000000"/>
-                </a:solidFill>
+                  <a:srgbClr val="FFFFFF"/>
+                </a:solidFill>
+                <a:latin typeface="Arial" pitchFamily="34" charset="0"/>
+                <a:ea typeface="Arial" pitchFamily="34" charset="-122"/>
+                <a:cs typeface="Arial" pitchFamily="34" charset="-120"/>
               </a:rPr>
               <a:t>📈</a:t>
             </a:r>
@@ -2565,24 +2610,24 @@
         </p:nvSpPr>
         <p:spPr>
           <a:xfrm>
-            <a:off x="594360" y="2194560"/>
-            <a:ext cx="3291840" cy="502920"/>
-          </a:xfrm>
-          <a:prstGeom prst="rect">
-            <a:avLst/>
-          </a:prstGeom>
-          <a:noFill/>
-          <a:ln/>
-        </p:spPr>
-        <p:txBody>
-          <a:bodyPr wrap="square" rtlCol="0" anchor="ctr"/>
-          <a:lstStyle/>
-          <a:p>
-            <a:pPr indent="0" marL="0">
-              <a:buNone/>
-            </a:pPr>
-            <a:r>
-              <a:rPr lang="en-US" sz="1600" b="1" dirty="0">
+            <a:off x="594360" y="2103120"/>
+            <a:ext cx="3383280" cy="457200"/>
+          </a:xfrm>
+          <a:prstGeom prst="rect">
+            <a:avLst/>
+          </a:prstGeom>
+          <a:noFill/>
+          <a:ln/>
+        </p:spPr>
+        <p:txBody>
+          <a:bodyPr wrap="square" rtlCol="0" anchor="ctr"/>
+          <a:lstStyle/>
+          <a:p>
+            <a:pPr indent="0" marL="0">
+              <a:buNone/>
+            </a:pPr>
+            <a:r>
+              <a:rPr lang="en-US" sz="1500" b="1" dirty="0">
                 <a:solidFill>
                   <a:srgbClr val="00D4FF"/>
                 </a:solidFill>
@@ -2592,7 +2637,7 @@
               </a:rPr>
               <a:t>Distribution is O(N)</a:t>
             </a:r>
-            <a:endParaRPr lang="en-US" sz="1600" dirty="0"/>
+            <a:endParaRPr lang="en-US" sz="1500" dirty="0"/>
           </a:p>
         </p:txBody>
       </p:sp>
@@ -2604,8 +2649,8 @@
         </p:nvSpPr>
         <p:spPr>
           <a:xfrm>
-            <a:off x="594360" y="2788920"/>
-            <a:ext cx="3291840" cy="2743200"/>
+            <a:off x="594360" y="2651760"/>
+            <a:ext cx="3383280" cy="2926080"/>
           </a:xfrm>
           <a:prstGeom prst="rect">
             <a:avLst/>
@@ -2629,7 +2674,7 @@
                 <a:ea typeface="Arial" pitchFamily="34" charset="-122"/>
                 <a:cs typeface="Arial" pitchFamily="34" charset="-120"/>
               </a:rPr>
-              <a:t>Ethereum, Solana, most L1s iterate over every participant to distribute rewards.</a:t>
+              <a:t>Ethereum, Solana and most L1s iterate over every participant to distribute rewards.</a:t>
             </a:r>
             <a:endParaRPr lang="en-US" sz="1300" dirty="0"/>
           </a:p>
@@ -2646,7 +2691,7 @@
                 <a:ea typeface="Arial" pitchFamily="34" charset="-122"/>
                 <a:cs typeface="Arial" pitchFamily="34" charset="-120"/>
               </a:rPr>
-              <a:t>At 1M users: 1M storage writes per distribution tick.</a:t>
+              <a:t>At 1M users: 1M storage writes per distribution tick. Gas cost scales linearly.</a:t>
             </a:r>
             <a:endParaRPr lang="en-US" sz="1300" dirty="0"/>
           </a:p>
@@ -2660,8 +2705,8 @@
         </p:nvSpPr>
         <p:spPr>
           <a:xfrm>
-            <a:off x="4297680" y="1280160"/>
-            <a:ext cx="3566160" cy="4389120"/>
+            <a:off x="4343400" y="1188720"/>
+            <a:ext cx="3657600" cy="4572000"/>
           </a:xfrm>
           <a:prstGeom prst="rect">
             <a:avLst/>
@@ -2685,8 +2730,8 @@
         </p:nvSpPr>
         <p:spPr>
           <a:xfrm>
-            <a:off x="4297680" y="1463040"/>
-            <a:ext cx="3566160" cy="640080"/>
+            <a:off x="4343400" y="1371600"/>
+            <a:ext cx="3657600" cy="640080"/>
           </a:xfrm>
           <a:prstGeom prst="rect">
             <a:avLst/>
@@ -2704,8 +2749,11 @@
             <a:r>
               <a:rPr lang="en-US" sz="3200" dirty="0">
                 <a:solidFill>
-                  <a:srgbClr val="000000"/>
-                </a:solidFill>
+                  <a:srgbClr val="FFFFFF"/>
+                </a:solidFill>
+                <a:latin typeface="Arial" pitchFamily="34" charset="0"/>
+                <a:ea typeface="Arial" pitchFamily="34" charset="-122"/>
+                <a:cs typeface="Arial" pitchFamily="34" charset="-120"/>
               </a:rPr>
               <a:t>🎲</a:t>
             </a:r>
@@ -2721,24 +2769,24 @@
         </p:nvSpPr>
         <p:spPr>
           <a:xfrm>
-            <a:off x="4434840" y="2194560"/>
-            <a:ext cx="3291840" cy="502920"/>
-          </a:xfrm>
-          <a:prstGeom prst="rect">
-            <a:avLst/>
-          </a:prstGeom>
-          <a:noFill/>
-          <a:ln/>
-        </p:spPr>
-        <p:txBody>
-          <a:bodyPr wrap="square" rtlCol="0" anchor="ctr"/>
-          <a:lstStyle/>
-          <a:p>
-            <a:pPr indent="0" marL="0">
-              <a:buNone/>
-            </a:pPr>
-            <a:r>
-              <a:rPr lang="en-US" sz="1600" b="1" dirty="0">
+            <a:off x="4480560" y="2103120"/>
+            <a:ext cx="3383280" cy="457200"/>
+          </a:xfrm>
+          <a:prstGeom prst="rect">
+            <a:avLst/>
+          </a:prstGeom>
+          <a:noFill/>
+          <a:ln/>
+        </p:spPr>
+        <p:txBody>
+          <a:bodyPr wrap="square" rtlCol="0" anchor="ctr"/>
+          <a:lstStyle/>
+          <a:p>
+            <a:pPr indent="0" marL="0">
+              <a:buNone/>
+            </a:pPr>
+            <a:r>
+              <a:rPr lang="en-US" sz="1500" b="1" dirty="0">
                 <a:solidFill>
                   <a:srgbClr val="00D4FF"/>
                 </a:solidFill>
@@ -2748,7 +2796,7 @@
               </a:rPr>
               <a:t>Consistency is Probabilistic</a:t>
             </a:r>
-            <a:endParaRPr lang="en-US" sz="1600" dirty="0"/>
+            <a:endParaRPr lang="en-US" sz="1500" dirty="0"/>
           </a:p>
         </p:txBody>
       </p:sp>
@@ -2760,8 +2808,8 @@
         </p:nvSpPr>
         <p:spPr>
           <a:xfrm>
-            <a:off x="4434840" y="2788920"/>
-            <a:ext cx="3291840" cy="2743200"/>
+            <a:off x="4480560" y="2651760"/>
+            <a:ext cx="3383280" cy="2926080"/>
           </a:xfrm>
           <a:prstGeom prst="rect">
             <a:avLst/>
@@ -2785,7 +2833,7 @@
                 <a:ea typeface="Arial" pitchFamily="34" charset="-122"/>
                 <a:cs typeface="Arial" pitchFamily="34" charset="-120"/>
               </a:rPr>
-              <a:t>State validity is assumed, not verified. Overflow bugs, accounting errors, and edge cases accumulate silently under load.</a:t>
+              <a:t>State validity is assumed, not verified after every operation. Overflow bugs and accounting errors accumulate silently under load.</a:t>
             </a:r>
             <a:endParaRPr lang="en-US" sz="1300" dirty="0"/>
           </a:p>
@@ -2799,8 +2847,8 @@
         </p:nvSpPr>
         <p:spPr>
           <a:xfrm>
-            <a:off x="8138160" y="1280160"/>
-            <a:ext cx="3566160" cy="4389120"/>
+            <a:off x="8229600" y="1188720"/>
+            <a:ext cx="3657600" cy="4572000"/>
           </a:xfrm>
           <a:prstGeom prst="rect">
             <a:avLst/>
@@ -2824,8 +2872,8 @@
         </p:nvSpPr>
         <p:spPr>
           <a:xfrm>
-            <a:off x="8138160" y="1463040"/>
-            <a:ext cx="3566160" cy="640080"/>
+            <a:off x="8229600" y="1371600"/>
+            <a:ext cx="3657600" cy="640080"/>
           </a:xfrm>
           <a:prstGeom prst="rect">
             <a:avLst/>
@@ -2843,8 +2891,11 @@
             <a:r>
               <a:rPr lang="en-US" sz="3200" dirty="0">
                 <a:solidFill>
-                  <a:srgbClr val="000000"/>
-                </a:solidFill>
+                  <a:srgbClr val="FFFFFF"/>
+                </a:solidFill>
+                <a:latin typeface="Arial" pitchFamily="34" charset="0"/>
+                <a:ea typeface="Arial" pitchFamily="34" charset="-122"/>
+                <a:cs typeface="Arial" pitchFamily="34" charset="-120"/>
               </a:rPr>
               <a:t>🔗</a:t>
             </a:r>
@@ -2860,24 +2911,24 @@
         </p:nvSpPr>
         <p:spPr>
           <a:xfrm>
-            <a:off x="8275320" y="2194560"/>
-            <a:ext cx="3291840" cy="502920"/>
-          </a:xfrm>
-          <a:prstGeom prst="rect">
-            <a:avLst/>
-          </a:prstGeom>
-          <a:noFill/>
-          <a:ln/>
-        </p:spPr>
-        <p:txBody>
-          <a:bodyPr wrap="square" rtlCol="0" anchor="ctr"/>
-          <a:lstStyle/>
-          <a:p>
-            <a:pPr indent="0" marL="0">
-              <a:buNone/>
-            </a:pPr>
-            <a:r>
-              <a:rPr lang="en-US" sz="1600" b="1" dirty="0">
+            <a:off x="8366760" y="2103120"/>
+            <a:ext cx="3383280" cy="457200"/>
+          </a:xfrm>
+          <a:prstGeom prst="rect">
+            <a:avLst/>
+          </a:prstGeom>
+          <a:noFill/>
+          <a:ln/>
+        </p:spPr>
+        <p:txBody>
+          <a:bodyPr wrap="square" rtlCol="0" anchor="ctr"/>
+          <a:lstStyle/>
+          <a:p>
+            <a:pPr indent="0" marL="0">
+              <a:buNone/>
+            </a:pPr>
+            <a:r>
+              <a:rPr lang="en-US" sz="1500" b="1" dirty="0">
                 <a:solidFill>
                   <a:srgbClr val="00D4FF"/>
                 </a:solidFill>
@@ -2885,9 +2936,9 @@
                 <a:ea typeface="Arial" pitchFamily="34" charset="-122"/>
                 <a:cs typeface="Arial" pitchFamily="34" charset="-120"/>
               </a:rPr>
-              <a:t>Economics Live Outside the Core</a:t>
-            </a:r>
-            <a:endParaRPr lang="en-US" sz="1600" dirty="0"/>
+              <a:t>Economics Outside the Core</a:t>
+            </a:r>
+            <a:endParaRPr lang="en-US" sz="1500" dirty="0"/>
           </a:p>
         </p:txBody>
       </p:sp>
@@ -2899,8 +2950,8 @@
         </p:nvSpPr>
         <p:spPr>
           <a:xfrm>
-            <a:off x="8275320" y="2788920"/>
-            <a:ext cx="3291840" cy="2743200"/>
+            <a:off x="8366760" y="2651760"/>
+            <a:ext cx="3383280" cy="2926080"/>
           </a:xfrm>
           <a:prstGeom prst="rect">
             <a:avLst/>
@@ -2924,7 +2975,7 @@
                 <a:ea typeface="Arial" pitchFamily="34" charset="-122"/>
                 <a:cs typeface="Arial" pitchFamily="34" charset="-120"/>
               </a:rPr>
-              <a:t>Fee logic, tokenomics, and distribution rules are in smart contracts — not in the protocol. Complexity and attack surface grow unbounded.</a:t>
+              <a:t>Fee logic and tokenomics live in smart contracts — not the protocol. Complexity and attack surface grow unbounded with each new contract.</a:t>
             </a:r>
             <a:endParaRPr lang="en-US" sz="1300" dirty="0"/>
           </a:p>
@@ -2970,7 +3021,7 @@
         </p:nvSpPr>
         <p:spPr>
           <a:xfrm>
-            <a:off x="457200" y="365760"/>
+            <a:off x="457200" y="320040"/>
             <a:ext cx="11247120" cy="640080"/>
           </a:xfrm>
           <a:prstGeom prst="rect">
@@ -3009,8 +3060,8 @@
         </p:nvSpPr>
         <p:spPr>
           <a:xfrm>
-            <a:off x="457200" y="1188720"/>
-            <a:ext cx="5303520" cy="2743200"/>
+            <a:off x="457200" y="1097280"/>
+            <a:ext cx="5394960" cy="2926080"/>
           </a:xfrm>
           <a:prstGeom prst="rect">
             <a:avLst/>
@@ -3034,7 +3085,7 @@
         </p:nvSpPr>
         <p:spPr>
           <a:xfrm>
-            <a:off x="594360" y="1325880"/>
+            <a:off x="640080" y="1234440"/>
             <a:ext cx="5029200" cy="365760"/>
           </a:xfrm>
           <a:prstGeom prst="rect">
@@ -3073,8 +3124,8 @@
         </p:nvSpPr>
         <p:spPr>
           <a:xfrm>
-            <a:off x="594360" y="1783080"/>
-            <a:ext cx="5029200" cy="502920"/>
+            <a:off x="640080" y="1691640"/>
+            <a:ext cx="5029200" cy="548640"/>
           </a:xfrm>
           <a:prstGeom prst="rect">
             <a:avLst/>
@@ -3112,8 +3163,8 @@
         </p:nvSpPr>
         <p:spPr>
           <a:xfrm>
-            <a:off x="594360" y="2377440"/>
-            <a:ext cx="5029200" cy="502920"/>
+            <a:off x="640080" y="2313432"/>
+            <a:ext cx="5029200" cy="548640"/>
           </a:xfrm>
           <a:prstGeom prst="rect">
             <a:avLst/>
@@ -3151,8 +3202,8 @@
         </p:nvSpPr>
         <p:spPr>
           <a:xfrm>
-            <a:off x="594360" y="2971800"/>
-            <a:ext cx="5029200" cy="502920"/>
+            <a:off x="640080" y="2935224"/>
+            <a:ext cx="5029200" cy="548640"/>
           </a:xfrm>
           <a:prstGeom prst="rect">
             <a:avLst/>
@@ -3190,8 +3241,8 @@
         </p:nvSpPr>
         <p:spPr>
           <a:xfrm>
-            <a:off x="6309360" y="1188720"/>
-            <a:ext cx="5486400" cy="2743200"/>
+            <a:off x="6400800" y="1097280"/>
+            <a:ext cx="5486400" cy="2926080"/>
           </a:xfrm>
           <a:prstGeom prst="rect">
             <a:avLst/>
@@ -3215,8 +3266,8 @@
         </p:nvSpPr>
         <p:spPr>
           <a:xfrm>
-            <a:off x="6400800" y="1234440"/>
-            <a:ext cx="1691640" cy="438912"/>
+            <a:off x="6492240" y="1143000"/>
+            <a:ext cx="1691640" cy="457200"/>
           </a:xfrm>
           <a:prstGeom prst="rect">
             <a:avLst/>
@@ -3254,8 +3305,8 @@
         </p:nvSpPr>
         <p:spPr>
           <a:xfrm>
-            <a:off x="8138160" y="1234440"/>
-            <a:ext cx="1691640" cy="438912"/>
+            <a:off x="8229600" y="1143000"/>
+            <a:ext cx="1691640" cy="457200"/>
           </a:xfrm>
           <a:prstGeom prst="rect">
             <a:avLst/>
@@ -3293,8 +3344,8 @@
         </p:nvSpPr>
         <p:spPr>
           <a:xfrm>
-            <a:off x="9875520" y="1234440"/>
-            <a:ext cx="1691640" cy="438912"/>
+            <a:off x="9966960" y="1143000"/>
+            <a:ext cx="1691640" cy="457200"/>
           </a:xfrm>
           <a:prstGeom prst="rect">
             <a:avLst/>
@@ -3332,8 +3383,8 @@
         </p:nvSpPr>
         <p:spPr>
           <a:xfrm>
-            <a:off x="6400800" y="1719072"/>
-            <a:ext cx="1691640" cy="438912"/>
+            <a:off x="6492240" y="1645920"/>
+            <a:ext cx="1691640" cy="457200"/>
           </a:xfrm>
           <a:prstGeom prst="rect">
             <a:avLst/>
@@ -3357,7 +3408,7 @@
                 <a:ea typeface="Arial" pitchFamily="34" charset="-122"/>
                 <a:cs typeface="Arial" pitchFamily="34" charset="-120"/>
               </a:rPr>
-              <a:t>Distribute to N users</a:t>
+              <a:t>Distribute N users</a:t>
             </a:r>
             <a:endParaRPr lang="en-US" sz="1300" dirty="0"/>
           </a:p>
@@ -3371,8 +3422,8 @@
         </p:nvSpPr>
         <p:spPr>
           <a:xfrm>
-            <a:off x="8138160" y="1719072"/>
-            <a:ext cx="1691640" cy="438912"/>
+            <a:off x="8229600" y="1645920"/>
+            <a:ext cx="1691640" cy="457200"/>
           </a:xfrm>
           <a:prstGeom prst="rect">
             <a:avLst/>
@@ -3410,8 +3461,8 @@
         </p:nvSpPr>
         <p:spPr>
           <a:xfrm>
-            <a:off x="9875520" y="1719072"/>
-            <a:ext cx="1691640" cy="438912"/>
+            <a:off x="9966960" y="1645920"/>
+            <a:ext cx="1691640" cy="457200"/>
           </a:xfrm>
           <a:prstGeom prst="rect">
             <a:avLst/>
@@ -3449,8 +3500,8 @@
         </p:nvSpPr>
         <p:spPr>
           <a:xfrm>
-            <a:off x="6400800" y="2203704"/>
-            <a:ext cx="1691640" cy="438912"/>
+            <a:off x="6492240" y="2148840"/>
+            <a:ext cx="1691640" cy="457200"/>
           </a:xfrm>
           <a:prstGeom prst="rect">
             <a:avLst/>
@@ -3488,8 +3539,8 @@
         </p:nvSpPr>
         <p:spPr>
           <a:xfrm>
-            <a:off x="8138160" y="2203704"/>
-            <a:ext cx="1691640" cy="438912"/>
+            <a:off x="8229600" y="2148840"/>
+            <a:ext cx="1691640" cy="457200"/>
           </a:xfrm>
           <a:prstGeom prst="rect">
             <a:avLst/>
@@ -3513,7 +3564,7 @@
                 <a:ea typeface="Arial" pitchFamily="34" charset="-122"/>
                 <a:cs typeface="Arial" pitchFamily="34" charset="-120"/>
               </a:rPr>
-              <a:t>Periodic / none</a:t>
+              <a:t>None / periodic</a:t>
             </a:r>
             <a:endParaRPr lang="en-US" sz="1300" dirty="0"/>
           </a:p>
@@ -3527,8 +3578,8 @@
         </p:nvSpPr>
         <p:spPr>
           <a:xfrm>
-            <a:off x="9875520" y="2203704"/>
-            <a:ext cx="1691640" cy="438912"/>
+            <a:off x="9966960" y="2148840"/>
+            <a:ext cx="1691640" cy="457200"/>
           </a:xfrm>
           <a:prstGeom prst="rect">
             <a:avLst/>
@@ -3566,8 +3617,8 @@
         </p:nvSpPr>
         <p:spPr>
           <a:xfrm>
-            <a:off x="6400800" y="2688336"/>
-            <a:ext cx="1691640" cy="438912"/>
+            <a:off x="6492240" y="2651760"/>
+            <a:ext cx="1691640" cy="457200"/>
           </a:xfrm>
           <a:prstGeom prst="rect">
             <a:avLst/>
@@ -3591,7 +3642,7 @@
                 <a:ea typeface="Arial" pitchFamily="34" charset="-122"/>
                 <a:cs typeface="Arial" pitchFamily="34" charset="-120"/>
               </a:rPr>
-              <a:t>Economics location</a:t>
+              <a:t>Economics</a:t>
             </a:r>
             <a:endParaRPr lang="en-US" sz="1300" dirty="0"/>
           </a:p>
@@ -3605,8 +3656,8 @@
         </p:nvSpPr>
         <p:spPr>
           <a:xfrm>
-            <a:off x="8138160" y="2688336"/>
-            <a:ext cx="1691640" cy="438912"/>
+            <a:off x="8229600" y="2651760"/>
+            <a:ext cx="1691640" cy="457200"/>
           </a:xfrm>
           <a:prstGeom prst="rect">
             <a:avLst/>
@@ -3644,8 +3695,8 @@
         </p:nvSpPr>
         <p:spPr>
           <a:xfrm>
-            <a:off x="9875520" y="2688336"/>
-            <a:ext cx="1691640" cy="438912"/>
+            <a:off x="9966960" y="2651760"/>
+            <a:ext cx="1691640" cy="457200"/>
           </a:xfrm>
           <a:prstGeom prst="rect">
             <a:avLst/>
@@ -3683,8 +3734,8 @@
         </p:nvSpPr>
         <p:spPr>
           <a:xfrm>
-            <a:off x="6400800" y="3172968"/>
-            <a:ext cx="1691640" cy="438912"/>
+            <a:off x="6492240" y="3154680"/>
+            <a:ext cx="1691640" cy="457200"/>
           </a:xfrm>
           <a:prstGeom prst="rect">
             <a:avLst/>
@@ -3722,8 +3773,8 @@
         </p:nvSpPr>
         <p:spPr>
           <a:xfrm>
-            <a:off x="8138160" y="3172968"/>
-            <a:ext cx="1691640" cy="438912"/>
+            <a:off x="8229600" y="3154680"/>
+            <a:ext cx="1691640" cy="457200"/>
           </a:xfrm>
           <a:prstGeom prst="rect">
             <a:avLst/>
@@ -3761,8 +3812,8 @@
         </p:nvSpPr>
         <p:spPr>
           <a:xfrm>
-            <a:off x="9875520" y="3172968"/>
-            <a:ext cx="1691640" cy="438912"/>
+            <a:off x="9966960" y="3154680"/>
+            <a:ext cx="1691640" cy="457200"/>
           </a:xfrm>
           <a:prstGeom prst="rect">
             <a:avLst/>
@@ -3800,7 +3851,7 @@
         </p:nvSpPr>
         <p:spPr>
           <a:xfrm>
-            <a:off x="457200" y="4206240"/>
+            <a:off x="457200" y="4251960"/>
             <a:ext cx="11247120" cy="411480"/>
           </a:xfrm>
           <a:prstGeom prst="rect">
@@ -3871,7 +3922,7 @@
         </p:nvSpPr>
         <p:spPr>
           <a:xfrm>
-            <a:off x="457200" y="365760"/>
+            <a:off x="457200" y="320040"/>
             <a:ext cx="11247120" cy="640080"/>
           </a:xfrm>
           <a:prstGeom prst="rect">
@@ -3910,8 +3961,8 @@
         </p:nvSpPr>
         <p:spPr>
           <a:xfrm>
-            <a:off x="457200" y="1188720"/>
-            <a:ext cx="5577840" cy="2606040"/>
+            <a:off x="457200" y="1143000"/>
+            <a:ext cx="5669280" cy="2651760"/>
           </a:xfrm>
           <a:prstGeom prst="rect">
             <a:avLst/>
@@ -3935,7 +3986,7 @@
         </p:nvSpPr>
         <p:spPr>
           <a:xfrm>
-            <a:off x="594360" y="1280160"/>
+            <a:off x="594360" y="1234440"/>
             <a:ext cx="640080" cy="411480"/>
           </a:xfrm>
           <a:prstGeom prst="rect">
@@ -3974,8 +4025,8 @@
         </p:nvSpPr>
         <p:spPr>
           <a:xfrm>
-            <a:off x="1280160" y="1280160"/>
-            <a:ext cx="4572000" cy="411480"/>
+            <a:off x="1280160" y="1234440"/>
+            <a:ext cx="4663440" cy="411480"/>
           </a:xfrm>
           <a:prstGeom prst="rect">
             <a:avLst/>
@@ -4013,8 +4064,8 @@
         </p:nvSpPr>
         <p:spPr>
           <a:xfrm>
-            <a:off x="594360" y="1783080"/>
-            <a:ext cx="5303520" cy="457200"/>
+            <a:off x="594360" y="1737360"/>
+            <a:ext cx="5394960" cy="457200"/>
           </a:xfrm>
           <a:prstGeom prst="rect">
             <a:avLst/>
@@ -4052,8 +4103,8 @@
         </p:nvSpPr>
         <p:spPr>
           <a:xfrm>
-            <a:off x="594360" y="2331720"/>
-            <a:ext cx="5303520" cy="1325880"/>
+            <a:off x="594360" y="2286000"/>
+            <a:ext cx="5394960" cy="1371600"/>
           </a:xfrm>
           <a:prstGeom prst="rect">
             <a:avLst/>
@@ -4077,7 +4128,7 @@
                 <a:ea typeface="Arial" pitchFamily="34" charset="-122"/>
                 <a:cs typeface="Arial" pitchFamily="34" charset="-120"/>
               </a:rPr>
-              <a:t>The total supply must always equal the scalar field contribution plus all individual base balances. No phantom tokens. Ever.</a:t>
+              <a:t>No phantom tokens. Total supply always equals scalar field contribution plus all base balances.</a:t>
             </a:r>
             <a:endParaRPr lang="en-US" sz="1300" dirty="0"/>
           </a:p>
@@ -4091,8 +4142,8 @@
         </p:nvSpPr>
         <p:spPr>
           <a:xfrm>
-            <a:off x="6309360" y="1188720"/>
-            <a:ext cx="5577840" cy="2606040"/>
+            <a:off x="6446520" y="1143000"/>
+            <a:ext cx="5669280" cy="2651760"/>
           </a:xfrm>
           <a:prstGeom prst="rect">
             <a:avLst/>
@@ -4116,7 +4167,7 @@
         </p:nvSpPr>
         <p:spPr>
           <a:xfrm>
-            <a:off x="6446520" y="1280160"/>
+            <a:off x="6583680" y="1234440"/>
             <a:ext cx="640080" cy="411480"/>
           </a:xfrm>
           <a:prstGeom prst="rect">
@@ -4155,8 +4206,8 @@
         </p:nvSpPr>
         <p:spPr>
           <a:xfrm>
-            <a:off x="7132320" y="1280160"/>
-            <a:ext cx="4572000" cy="411480"/>
+            <a:off x="7269480" y="1234440"/>
+            <a:ext cx="4663440" cy="411480"/>
           </a:xfrm>
           <a:prstGeom prst="rect">
             <a:avLst/>
@@ -4194,8 +4245,8 @@
         </p:nvSpPr>
         <p:spPr>
           <a:xfrm>
-            <a:off x="6446520" y="1783080"/>
-            <a:ext cx="5303520" cy="457200"/>
+            <a:off x="6583680" y="1737360"/>
+            <a:ext cx="5394960" cy="457200"/>
           </a:xfrm>
           <a:prstGeom prst="rect">
             <a:avLst/>
@@ -4233,8 +4284,8 @@
         </p:nvSpPr>
         <p:spPr>
           <a:xfrm>
-            <a:off x="6446520" y="2331720"/>
-            <a:ext cx="5303520" cy="1325880"/>
+            <a:off x="6583680" y="2286000"/>
+            <a:ext cx="5394960" cy="1371600"/>
           </a:xfrm>
           <a:prstGeom prst="rect">
             <a:avLst/>
@@ -4258,7 +4309,7 @@
                 <a:ea typeface="Arial" pitchFamily="34" charset="-122"/>
                 <a:cs typeface="Arial" pitchFamily="34" charset="-120"/>
               </a:rPr>
-              <a:t>Every token in existence is accounted for by creation and destruction events. Double-spending is structurally impossible.</a:t>
+              <a:t>Every token is accounted for by creation and destruction. Double-spending is structurally impossible.</a:t>
             </a:r>
             <a:endParaRPr lang="en-US" sz="1300" dirty="0"/>
           </a:p>
@@ -4272,8 +4323,8 @@
         </p:nvSpPr>
         <p:spPr>
           <a:xfrm>
-            <a:off x="457200" y="4023360"/>
-            <a:ext cx="5577840" cy="2606040"/>
+            <a:off x="457200" y="3977640"/>
+            <a:ext cx="5669280" cy="2651760"/>
           </a:xfrm>
           <a:prstGeom prst="rect">
             <a:avLst/>
@@ -4297,7 +4348,7 @@
         </p:nvSpPr>
         <p:spPr>
           <a:xfrm>
-            <a:off x="594360" y="4114800"/>
+            <a:off x="594360" y="4069080"/>
             <a:ext cx="640080" cy="411480"/>
           </a:xfrm>
           <a:prstGeom prst="rect">
@@ -4336,8 +4387,8 @@
         </p:nvSpPr>
         <p:spPr>
           <a:xfrm>
-            <a:off x="1280160" y="4114800"/>
-            <a:ext cx="4572000" cy="411480"/>
+            <a:off x="1280160" y="4069080"/>
+            <a:ext cx="4663440" cy="411480"/>
           </a:xfrm>
           <a:prstGeom prst="rect">
             <a:avLst/>
@@ -4375,8 +4426,8 @@
         </p:nvSpPr>
         <p:spPr>
           <a:xfrm>
-            <a:off x="594360" y="4617720"/>
-            <a:ext cx="5303520" cy="457200"/>
+            <a:off x="594360" y="4572000"/>
+            <a:ext cx="5394960" cy="457200"/>
           </a:xfrm>
           <a:prstGeom prst="rect">
             <a:avLst/>
@@ -4414,8 +4465,8 @@
         </p:nvSpPr>
         <p:spPr>
           <a:xfrm>
-            <a:off x="594360" y="5166360"/>
-            <a:ext cx="5303520" cy="1325880"/>
+            <a:off x="594360" y="5120640"/>
+            <a:ext cx="5394960" cy="1371600"/>
           </a:xfrm>
           <a:prstGeom prst="rect">
             <a:avLst/>
@@ -4439,7 +4490,7 @@
                 <a:ea typeface="Arial" pitchFamily="34" charset="-122"/>
                 <a:cs typeface="Arial" pitchFamily="34" charset="-120"/>
               </a:rPr>
-              <a:t>Rounding remainder from redistribution is always strictly less than the participant count. Fuzz-verified including the unregister edge case.</a:t>
+              <a:t>Rounding remainder from redistribution is always strictly less than participant count. Fuzz-verified.</a:t>
             </a:r>
             <a:endParaRPr lang="en-US" sz="1300" dirty="0"/>
           </a:p>
@@ -4453,8 +4504,8 @@
         </p:nvSpPr>
         <p:spPr>
           <a:xfrm>
-            <a:off x="6309360" y="4023360"/>
-            <a:ext cx="5577840" cy="2606040"/>
+            <a:off x="6446520" y="3977640"/>
+            <a:ext cx="5669280" cy="2651760"/>
           </a:xfrm>
           <a:prstGeom prst="rect">
             <a:avLst/>
@@ -4478,7 +4529,7 @@
         </p:nvSpPr>
         <p:spPr>
           <a:xfrm>
-            <a:off x="6446520" y="4114800"/>
+            <a:off x="6583680" y="4069080"/>
             <a:ext cx="640080" cy="411480"/>
           </a:xfrm>
           <a:prstGeom prst="rect">
@@ -4517,8 +4568,8 @@
         </p:nvSpPr>
         <p:spPr>
           <a:xfrm>
-            <a:off x="7132320" y="4114800"/>
-            <a:ext cx="4572000" cy="411480"/>
+            <a:off x="7269480" y="4069080"/>
+            <a:ext cx="4663440" cy="411480"/>
           </a:xfrm>
           <a:prstGeom prst="rect">
             <a:avLst/>
@@ -4556,8 +4607,8 @@
         </p:nvSpPr>
         <p:spPr>
           <a:xfrm>
-            <a:off x="6446520" y="4617720"/>
-            <a:ext cx="5303520" cy="457200"/>
+            <a:off x="6583680" y="4572000"/>
+            <a:ext cx="5394960" cy="457200"/>
           </a:xfrm>
           <a:prstGeom prst="rect">
             <a:avLst/>
@@ -4595,8 +4646,8 @@
         </p:nvSpPr>
         <p:spPr>
           <a:xfrm>
-            <a:off x="6446520" y="5166360"/>
-            <a:ext cx="5303520" cy="1325880"/>
+            <a:off x="6583680" y="5120640"/>
+            <a:ext cx="5394960" cy="1371600"/>
           </a:xfrm>
           <a:prstGeom prst="rect">
             <a:avLst/>
@@ -4620,7 +4671,7 @@
                 <a:ea typeface="Arial" pitchFamily="34" charset="-122"/>
                 <a:cs typeface="Arial" pitchFamily="34" charset="-120"/>
               </a:rPr>
-              <a:t>No participant can hold unlimited debt. Exit is blocked when effective balance is negative. Prevents supply corruption on departure.</a:t>
+              <a:t>No participant can hold unlimited debt. Exit is blocked when effective balance is negative.</a:t>
             </a:r>
             <a:endParaRPr lang="en-US" sz="1300" dirty="0"/>
           </a:p>
@@ -4666,7 +4717,7 @@
         </p:nvSpPr>
         <p:spPr>
           <a:xfrm>
-            <a:off x="457200" y="365760"/>
+            <a:off x="457200" y="320040"/>
             <a:ext cx="11247120" cy="640080"/>
           </a:xfrm>
           <a:prstGeom prst="rect">
@@ -4691,7 +4742,7 @@
                 <a:ea typeface="Arial" pitchFamily="34" charset="-122"/>
                 <a:cs typeface="Arial" pitchFamily="34" charset="-120"/>
               </a:rPr>
-              <a:t>256,150,000+ Operations. Zero Violations.</a:t>
+              <a:t>Stress Test Results: Verified at Scale</a:t>
             </a:r>
             <a:endParaRPr lang="en-US" sz="3200" dirty="0"/>
           </a:p>
@@ -4705,8 +4756,8 @@
         </p:nvSpPr>
         <p:spPr>
           <a:xfrm>
-            <a:off x="457200" y="1097280"/>
-            <a:ext cx="3200400" cy="2286000"/>
+            <a:off x="457200" y="1005840"/>
+            <a:ext cx="3200400" cy="2560320"/>
           </a:xfrm>
           <a:prstGeom prst="rect">
             <a:avLst/>
@@ -4722,7 +4773,7 @@
               <a:buNone/>
             </a:pPr>
             <a:r>
-              <a:rPr lang="en-US" sz="12000" b="1" dirty="0">
+              <a:rPr lang="en-US" sz="13000" b="1" dirty="0">
                 <a:solidFill>
                   <a:srgbClr val="10B981"/>
                 </a:solidFill>
@@ -4732,7 +4783,7 @@
               </a:rPr>
               <a:t>0</a:t>
             </a:r>
-            <a:endParaRPr lang="en-US" sz="12000" dirty="0"/>
+            <a:endParaRPr lang="en-US" sz="13000" dirty="0"/>
           </a:p>
         </p:txBody>
       </p:sp>
@@ -4744,7 +4795,7 @@
         </p:nvSpPr>
         <p:spPr>
           <a:xfrm>
-            <a:off x="457200" y="3337560"/>
+            <a:off x="457200" y="3520440"/>
             <a:ext cx="3200400" cy="731520"/>
           </a:xfrm>
           <a:prstGeom prst="rect">
@@ -4801,723 +4852,13 @@
         <p:spPr>
           <a:xfrm>
             <a:off x="3931920" y="1097280"/>
-            <a:ext cx="2514600" cy="1417320"/>
+            <a:ext cx="3657600" cy="1600200"/>
           </a:xfrm>
           <a:prstGeom prst="rect">
             <a:avLst/>
           </a:prstGeom>
           <a:solidFill>
-            <a:srgbClr val="1F2937"/>
-          </a:solidFill>
-          <a:ln w="12700">
-            <a:solidFill>
-              <a:srgbClr val="7C3AED"/>
-            </a:solidFill>
-            <a:prstDash val="solid"/>
-          </a:ln>
-        </p:spPr>
-      </p:sp>
-      <p:sp>
-        <p:nvSpPr>
-          <p:cNvPr id="6" name="Text 4"/>
-          <p:cNvSpPr/>
-          <p:nvPr/>
-        </p:nvSpPr>
-        <p:spPr>
-          <a:xfrm>
-            <a:off x="4023360" y="1170432"/>
-            <a:ext cx="2331720" cy="320040"/>
-          </a:xfrm>
-          <a:prstGeom prst="rect">
-            <a:avLst/>
-          </a:prstGeom>
-          <a:noFill/>
-          <a:ln/>
-        </p:spPr>
-        <p:txBody>
-          <a:bodyPr wrap="square" rtlCol="0" anchor="ctr"/>
-          <a:lstStyle/>
-          <a:p>
-            <a:pPr indent="0" marL="0">
-              <a:buNone/>
-            </a:pPr>
-            <a:r>
-              <a:rPr lang="en-US" sz="1300" b="1" dirty="0">
-                <a:solidFill>
-                  <a:srgbClr val="00D4FF"/>
-                </a:solidFill>
-                <a:latin typeface="Arial" pitchFamily="34" charset="0"/>
-                <a:ea typeface="Arial" pitchFamily="34" charset="-122"/>
-                <a:cs typeface="Arial" pitchFamily="34" charset="-120"/>
-              </a:rPr>
-              <a:t>Mode 0</a:t>
-            </a:r>
-            <a:endParaRPr lang="en-US" sz="1300" dirty="0"/>
-          </a:p>
-        </p:txBody>
-      </p:sp>
-      <p:sp>
-        <p:nvSpPr>
-          <p:cNvPr id="7" name="Text 5"/>
-          <p:cNvSpPr/>
-          <p:nvPr/>
-        </p:nvSpPr>
-        <p:spPr>
-          <a:xfrm>
-            <a:off x="4023360" y="1508760"/>
-            <a:ext cx="2331720" cy="320040"/>
-          </a:xfrm>
-          <a:prstGeom prst="rect">
-            <a:avLst/>
-          </a:prstGeom>
-          <a:noFill/>
-          <a:ln/>
-        </p:spPr>
-        <p:txBody>
-          <a:bodyPr wrap="square" rtlCol="0" anchor="ctr"/>
-          <a:lstStyle/>
-          <a:p>
-            <a:pPr indent="0" marL="0">
-              <a:buNone/>
-            </a:pPr>
-            <a:r>
-              <a:rPr lang="en-US" sz="1300" b="1" dirty="0">
-                <a:solidFill>
-                  <a:srgbClr val="FFFFFF"/>
-                </a:solidFill>
-                <a:latin typeface="Arial" pitchFamily="34" charset="0"/>
-                <a:ea typeface="Arial" pitchFamily="34" charset="-122"/>
-                <a:cs typeface="Arial" pitchFamily="34" charset="-120"/>
-              </a:rPr>
-              <a:t>NEG_E Boundary</a:t>
-            </a:r>
-            <a:endParaRPr lang="en-US" sz="1300" dirty="0"/>
-          </a:p>
-        </p:txBody>
-      </p:sp>
-      <p:sp>
-        <p:nvSpPr>
-          <p:cNvPr id="8" name="Text 6"/>
-          <p:cNvSpPr/>
-          <p:nvPr/>
-        </p:nvSpPr>
-        <p:spPr>
-          <a:xfrm>
-            <a:off x="4023360" y="1874520"/>
-            <a:ext cx="2331720" cy="548640"/>
-          </a:xfrm>
-          <a:prstGeom prst="rect">
-            <a:avLst/>
-          </a:prstGeom>
-          <a:noFill/>
-          <a:ln/>
-        </p:spPr>
-        <p:txBody>
-          <a:bodyPr wrap="square" rtlCol="0" anchor="ctr"/>
-          <a:lstStyle/>
-          <a:p>
-            <a:pPr indent="0" marL="0">
-              <a:buNone/>
-            </a:pPr>
-            <a:r>
-              <a:rPr lang="en-US" sz="1100" dirty="0">
-                <a:solidFill>
-                  <a:srgbClr val="A0AEC0"/>
-                </a:solidFill>
-                <a:latin typeface="Arial" pitchFamily="34" charset="0"/>
-                <a:ea typeface="Arial" pitchFamily="34" charset="-122"/>
-                <a:cs typeface="Arial" pitchFamily="34" charset="-120"/>
-              </a:rPr>
-              <a:t>Overflow guard on apply_neg_entropy</a:t>
-            </a:r>
-            <a:endParaRPr lang="en-US" sz="1100" dirty="0"/>
-          </a:p>
-        </p:txBody>
-      </p:sp>
-      <p:sp>
-        <p:nvSpPr>
-          <p:cNvPr id="9" name="Shape 7"/>
-          <p:cNvSpPr/>
-          <p:nvPr/>
-        </p:nvSpPr>
-        <p:spPr>
-          <a:xfrm>
-            <a:off x="6629400" y="1097280"/>
-            <a:ext cx="2514600" cy="1417320"/>
-          </a:xfrm>
-          <a:prstGeom prst="rect">
-            <a:avLst/>
-          </a:prstGeom>
-          <a:solidFill>
-            <a:srgbClr val="1F2937"/>
-          </a:solidFill>
-          <a:ln w="12700">
-            <a:solidFill>
-              <a:srgbClr val="7C3AED"/>
-            </a:solidFill>
-            <a:prstDash val="solid"/>
-          </a:ln>
-        </p:spPr>
-      </p:sp>
-      <p:sp>
-        <p:nvSpPr>
-          <p:cNvPr id="10" name="Text 8"/>
-          <p:cNvSpPr/>
-          <p:nvPr/>
-        </p:nvSpPr>
-        <p:spPr>
-          <a:xfrm>
-            <a:off x="6720840" y="1170432"/>
-            <a:ext cx="2331720" cy="320040"/>
-          </a:xfrm>
-          <a:prstGeom prst="rect">
-            <a:avLst/>
-          </a:prstGeom>
-          <a:noFill/>
-          <a:ln/>
-        </p:spPr>
-        <p:txBody>
-          <a:bodyPr wrap="square" rtlCol="0" anchor="ctr"/>
-          <a:lstStyle/>
-          <a:p>
-            <a:pPr indent="0" marL="0">
-              <a:buNone/>
-            </a:pPr>
-            <a:r>
-              <a:rPr lang="en-US" sz="1300" b="1" dirty="0">
-                <a:solidFill>
-                  <a:srgbClr val="00D4FF"/>
-                </a:solidFill>
-                <a:latin typeface="Arial" pitchFamily="34" charset="0"/>
-                <a:ea typeface="Arial" pitchFamily="34" charset="-122"/>
-                <a:cs typeface="Arial" pitchFamily="34" charset="-120"/>
-              </a:rPr>
-              <a:t>Mode 1</a:t>
-            </a:r>
-            <a:endParaRPr lang="en-US" sz="1300" dirty="0"/>
-          </a:p>
-        </p:txBody>
-      </p:sp>
-      <p:sp>
-        <p:nvSpPr>
-          <p:cNvPr id="11" name="Text 9"/>
-          <p:cNvSpPr/>
-          <p:nvPr/>
-        </p:nvSpPr>
-        <p:spPr>
-          <a:xfrm>
-            <a:off x="6720840" y="1508760"/>
-            <a:ext cx="2331720" cy="320040"/>
-          </a:xfrm>
-          <a:prstGeom prst="rect">
-            <a:avLst/>
-          </a:prstGeom>
-          <a:noFill/>
-          <a:ln/>
-        </p:spPr>
-        <p:txBody>
-          <a:bodyPr wrap="square" rtlCol="0" anchor="ctr"/>
-          <a:lstStyle/>
-          <a:p>
-            <a:pPr indent="0" marL="0">
-              <a:buNone/>
-            </a:pPr>
-            <a:r>
-              <a:rPr lang="en-US" sz="1300" b="1" dirty="0">
-                <a:solidFill>
-                  <a:srgbClr val="FFFFFF"/>
-                </a:solidFill>
-                <a:latin typeface="Arial" pitchFamily="34" charset="0"/>
-                <a:ea typeface="Arial" pitchFamily="34" charset="-122"/>
-                <a:cs typeface="Arial" pitchFamily="34" charset="-120"/>
-              </a:rPr>
-              <a:t>Large p / Dust</a:t>
-            </a:r>
-            <a:endParaRPr lang="en-US" sz="1300" dirty="0"/>
-          </a:p>
-        </p:txBody>
-      </p:sp>
-      <p:sp>
-        <p:nvSpPr>
-          <p:cNvPr id="12" name="Text 10"/>
-          <p:cNvSpPr/>
-          <p:nvPr/>
-        </p:nvSpPr>
-        <p:spPr>
-          <a:xfrm>
-            <a:off x="6720840" y="1874520"/>
-            <a:ext cx="2331720" cy="548640"/>
-          </a:xfrm>
-          <a:prstGeom prst="rect">
-            <a:avLst/>
-          </a:prstGeom>
-          <a:noFill/>
-          <a:ln/>
-        </p:spPr>
-        <p:txBody>
-          <a:bodyPr wrap="square" rtlCol="0" anchor="ctr"/>
-          <a:lstStyle/>
-          <a:p>
-            <a:pPr indent="0" marL="0">
-              <a:buNone/>
-            </a:pPr>
-            <a:r>
-              <a:rPr lang="en-US" sz="1100" dirty="0">
-                <a:solidFill>
-                  <a:srgbClr val="A0AEC0"/>
-                </a:solidFill>
-                <a:latin typeface="Arial" pitchFamily="34" charset="0"/>
-                <a:ea typeface="Arial" pitchFamily="34" charset="-122"/>
-                <a:cs typeface="Arial" pitchFamily="34" charset="-120"/>
-              </a:rPr>
-              <a:t>Redistribution edge cases at scale</a:t>
-            </a:r>
-            <a:endParaRPr lang="en-US" sz="1100" dirty="0"/>
-          </a:p>
-        </p:txBody>
-      </p:sp>
-      <p:sp>
-        <p:nvSpPr>
-          <p:cNvPr id="13" name="Shape 11"/>
-          <p:cNvSpPr/>
-          <p:nvPr/>
-        </p:nvSpPr>
-        <p:spPr>
-          <a:xfrm>
-            <a:off x="9326880" y="1097280"/>
-            <a:ext cx="2514600" cy="1417320"/>
-          </a:xfrm>
-          <a:prstGeom prst="rect">
-            <a:avLst/>
-          </a:prstGeom>
-          <a:solidFill>
-            <a:srgbClr val="1F2937"/>
-          </a:solidFill>
-          <a:ln w="12700">
-            <a:solidFill>
-              <a:srgbClr val="7C3AED"/>
-            </a:solidFill>
-            <a:prstDash val="solid"/>
-          </a:ln>
-        </p:spPr>
-      </p:sp>
-      <p:sp>
-        <p:nvSpPr>
-          <p:cNvPr id="14" name="Text 12"/>
-          <p:cNvSpPr/>
-          <p:nvPr/>
-        </p:nvSpPr>
-        <p:spPr>
-          <a:xfrm>
-            <a:off x="9418320" y="1170432"/>
-            <a:ext cx="2331720" cy="320040"/>
-          </a:xfrm>
-          <a:prstGeom prst="rect">
-            <a:avLst/>
-          </a:prstGeom>
-          <a:noFill/>
-          <a:ln/>
-        </p:spPr>
-        <p:txBody>
-          <a:bodyPr wrap="square" rtlCol="0" anchor="ctr"/>
-          <a:lstStyle/>
-          <a:p>
-            <a:pPr indent="0" marL="0">
-              <a:buNone/>
-            </a:pPr>
-            <a:r>
-              <a:rPr lang="en-US" sz="1300" b="1" dirty="0">
-                <a:solidFill>
-                  <a:srgbClr val="00D4FF"/>
-                </a:solidFill>
-                <a:latin typeface="Arial" pitchFamily="34" charset="0"/>
-                <a:ea typeface="Arial" pitchFamily="34" charset="-122"/>
-                <a:cs typeface="Arial" pitchFamily="34" charset="-120"/>
-              </a:rPr>
-              <a:t>Mode 2</a:t>
-            </a:r>
-            <a:endParaRPr lang="en-US" sz="1300" dirty="0"/>
-          </a:p>
-        </p:txBody>
-      </p:sp>
-      <p:sp>
-        <p:nvSpPr>
-          <p:cNvPr id="15" name="Text 13"/>
-          <p:cNvSpPr/>
-          <p:nvPr/>
-        </p:nvSpPr>
-        <p:spPr>
-          <a:xfrm>
-            <a:off x="9418320" y="1508760"/>
-            <a:ext cx="2331720" cy="320040"/>
-          </a:xfrm>
-          <a:prstGeom prst="rect">
-            <a:avLst/>
-          </a:prstGeom>
-          <a:noFill/>
-          <a:ln/>
-        </p:spPr>
-        <p:txBody>
-          <a:bodyPr wrap="square" rtlCol="0" anchor="ctr"/>
-          <a:lstStyle/>
-          <a:p>
-            <a:pPr indent="0" marL="0">
-              <a:buNone/>
-            </a:pPr>
-            <a:r>
-              <a:rPr lang="en-US" sz="1300" b="1" dirty="0">
-                <a:solidFill>
-                  <a:srgbClr val="FFFFFF"/>
-                </a:solidFill>
-                <a:latin typeface="Arial" pitchFamily="34" charset="0"/>
-                <a:ea typeface="Arial" pitchFamily="34" charset="-122"/>
-                <a:cs typeface="Arial" pitchFamily="34" charset="-120"/>
-              </a:rPr>
-              <a:t>Negative Field</a:t>
-            </a:r>
-            <a:endParaRPr lang="en-US" sz="1300" dirty="0"/>
-          </a:p>
-        </p:txBody>
-      </p:sp>
-      <p:sp>
-        <p:nvSpPr>
-          <p:cNvPr id="16" name="Text 14"/>
-          <p:cNvSpPr/>
-          <p:nvPr/>
-        </p:nvSpPr>
-        <p:spPr>
-          <a:xfrm>
-            <a:off x="9418320" y="1874520"/>
-            <a:ext cx="2331720" cy="548640"/>
-          </a:xfrm>
-          <a:prstGeom prst="rect">
-            <a:avLst/>
-          </a:prstGeom>
-          <a:noFill/>
-          <a:ln/>
-        </p:spPr>
-        <p:txBody>
-          <a:bodyPr wrap="square" rtlCol="0" anchor="ctr"/>
-          <a:lstStyle/>
-          <a:p>
-            <a:pPr indent="0" marL="0">
-              <a:buNone/>
-            </a:pPr>
-            <a:r>
-              <a:rPr lang="en-US" sz="1100" dirty="0">
-                <a:solidFill>
-                  <a:srgbClr val="A0AEC0"/>
-                </a:solidFill>
-                <a:latin typeface="Arial" pitchFamily="34" charset="0"/>
-                <a:ea typeface="Arial" pitchFamily="34" charset="-122"/>
-                <a:cs typeface="Arial" pitchFamily="34" charset="-120"/>
-              </a:rPr>
-              <a:t>Debt limit &amp; DebtOnExit path</a:t>
-            </a:r>
-            <a:endParaRPr lang="en-US" sz="1100" dirty="0"/>
-          </a:p>
-        </p:txBody>
-      </p:sp>
-      <p:sp>
-        <p:nvSpPr>
-          <p:cNvPr id="17" name="Shape 15"/>
-          <p:cNvSpPr/>
-          <p:nvPr/>
-        </p:nvSpPr>
-        <p:spPr>
-          <a:xfrm>
-            <a:off x="3931920" y="2743200"/>
-            <a:ext cx="2514600" cy="1417320"/>
-          </a:xfrm>
-          <a:prstGeom prst="rect">
-            <a:avLst/>
-          </a:prstGeom>
-          <a:solidFill>
-            <a:srgbClr val="1F2937"/>
-          </a:solidFill>
-          <a:ln w="12700">
-            <a:solidFill>
-              <a:srgbClr val="7C3AED"/>
-            </a:solidFill>
-            <a:prstDash val="solid"/>
-          </a:ln>
-        </p:spPr>
-      </p:sp>
-      <p:sp>
-        <p:nvSpPr>
-          <p:cNvPr id="18" name="Text 16"/>
-          <p:cNvSpPr/>
-          <p:nvPr/>
-        </p:nvSpPr>
-        <p:spPr>
-          <a:xfrm>
-            <a:off x="4023360" y="2816352"/>
-            <a:ext cx="2331720" cy="320040"/>
-          </a:xfrm>
-          <a:prstGeom prst="rect">
-            <a:avLst/>
-          </a:prstGeom>
-          <a:noFill/>
-          <a:ln/>
-        </p:spPr>
-        <p:txBody>
-          <a:bodyPr wrap="square" rtlCol="0" anchor="ctr"/>
-          <a:lstStyle/>
-          <a:p>
-            <a:pPr indent="0" marL="0">
-              <a:buNone/>
-            </a:pPr>
-            <a:r>
-              <a:rPr lang="en-US" sz="1300" b="1" dirty="0">
-                <a:solidFill>
-                  <a:srgbClr val="00D4FF"/>
-                </a:solidFill>
-                <a:latin typeface="Arial" pitchFamily="34" charset="0"/>
-                <a:ea typeface="Arial" pitchFamily="34" charset="-122"/>
-                <a:cs typeface="Arial" pitchFamily="34" charset="-120"/>
-              </a:rPr>
-              <a:t>Mode 3</a:t>
-            </a:r>
-            <a:endParaRPr lang="en-US" sz="1300" dirty="0"/>
-          </a:p>
-        </p:txBody>
-      </p:sp>
-      <p:sp>
-        <p:nvSpPr>
-          <p:cNvPr id="19" name="Text 17"/>
-          <p:cNvSpPr/>
-          <p:nvPr/>
-        </p:nvSpPr>
-        <p:spPr>
-          <a:xfrm>
-            <a:off x="4023360" y="3154680"/>
-            <a:ext cx="2331720" cy="320040"/>
-          </a:xfrm>
-          <a:prstGeom prst="rect">
-            <a:avLst/>
-          </a:prstGeom>
-          <a:noFill/>
-          <a:ln/>
-        </p:spPr>
-        <p:txBody>
-          <a:bodyPr wrap="square" rtlCol="0" anchor="ctr"/>
-          <a:lstStyle/>
-          <a:p>
-            <a:pPr indent="0" marL="0">
-              <a:buNone/>
-            </a:pPr>
-            <a:r>
-              <a:rPr lang="en-US" sz="1300" b="1" dirty="0">
-                <a:solidFill>
-                  <a:srgbClr val="FFFFFF"/>
-                </a:solidFill>
-                <a:latin typeface="Arial" pitchFamily="34" charset="0"/>
-                <a:ea typeface="Arial" pitchFamily="34" charset="-122"/>
-                <a:cs typeface="Arial" pitchFamily="34" charset="-120"/>
-              </a:rPr>
-              <a:t>p = 0 Edge</a:t>
-            </a:r>
-            <a:endParaRPr lang="en-US" sz="1300" dirty="0"/>
-          </a:p>
-        </p:txBody>
-      </p:sp>
-      <p:sp>
-        <p:nvSpPr>
-          <p:cNvPr id="20" name="Text 18"/>
-          <p:cNvSpPr/>
-          <p:nvPr/>
-        </p:nvSpPr>
-        <p:spPr>
-          <a:xfrm>
-            <a:off x="4023360" y="3520440"/>
-            <a:ext cx="2331720" cy="548640"/>
-          </a:xfrm>
-          <a:prstGeom prst="rect">
-            <a:avLst/>
-          </a:prstGeom>
-          <a:noFill/>
-          <a:ln/>
-        </p:spPr>
-        <p:txBody>
-          <a:bodyPr wrap="square" rtlCol="0" anchor="ctr"/>
-          <a:lstStyle/>
-          <a:p>
-            <a:pPr indent="0" marL="0">
-              <a:buNone/>
-            </a:pPr>
-            <a:r>
-              <a:rPr lang="en-US" sz="1100" dirty="0">
-                <a:solidFill>
-                  <a:srgbClr val="A0AEC0"/>
-                </a:solidFill>
-                <a:latin typeface="Arial" pitchFamily="34" charset="0"/>
-                <a:ea typeface="Arial" pitchFamily="34" charset="-122"/>
-                <a:cs typeface="Arial" pitchFamily="34" charset="-120"/>
-              </a:rPr>
-              <a:t>Zero-participant transitions</a:t>
-            </a:r>
-            <a:endParaRPr lang="en-US" sz="1100" dirty="0"/>
-          </a:p>
-        </p:txBody>
-      </p:sp>
-      <p:sp>
-        <p:nvSpPr>
-          <p:cNvPr id="21" name="Shape 19"/>
-          <p:cNvSpPr/>
-          <p:nvPr/>
-        </p:nvSpPr>
-        <p:spPr>
-          <a:xfrm>
-            <a:off x="6629400" y="2743200"/>
-            <a:ext cx="2514600" cy="1417320"/>
-          </a:xfrm>
-          <a:prstGeom prst="rect">
-            <a:avLst/>
-          </a:prstGeom>
-          <a:solidFill>
-            <a:srgbClr val="1F2937"/>
-          </a:solidFill>
-          <a:ln w="12700">
-            <a:solidFill>
-              <a:srgbClr val="7C3AED"/>
-            </a:solidFill>
-            <a:prstDash val="solid"/>
-          </a:ln>
-        </p:spPr>
-      </p:sp>
-      <p:sp>
-        <p:nvSpPr>
-          <p:cNvPr id="22" name="Text 20"/>
-          <p:cNvSpPr/>
-          <p:nvPr/>
-        </p:nvSpPr>
-        <p:spPr>
-          <a:xfrm>
-            <a:off x="6720840" y="2816352"/>
-            <a:ext cx="2331720" cy="320040"/>
-          </a:xfrm>
-          <a:prstGeom prst="rect">
-            <a:avLst/>
-          </a:prstGeom>
-          <a:noFill/>
-          <a:ln/>
-        </p:spPr>
-        <p:txBody>
-          <a:bodyPr wrap="square" rtlCol="0" anchor="ctr"/>
-          <a:lstStyle/>
-          <a:p>
-            <a:pPr indent="0" marL="0">
-              <a:buNone/>
-            </a:pPr>
-            <a:r>
-              <a:rPr lang="en-US" sz="1300" b="1" dirty="0">
-                <a:solidFill>
-                  <a:srgbClr val="00D4FF"/>
-                </a:solidFill>
-                <a:latin typeface="Arial" pitchFamily="34" charset="0"/>
-                <a:ea typeface="Arial" pitchFamily="34" charset="-122"/>
-                <a:cs typeface="Arial" pitchFamily="34" charset="-120"/>
-              </a:rPr>
-              <a:t>Mode 4</a:t>
-            </a:r>
-            <a:endParaRPr lang="en-US" sz="1300" dirty="0"/>
-          </a:p>
-        </p:txBody>
-      </p:sp>
-      <p:sp>
-        <p:nvSpPr>
-          <p:cNvPr id="23" name="Text 21"/>
-          <p:cNvSpPr/>
-          <p:nvPr/>
-        </p:nvSpPr>
-        <p:spPr>
-          <a:xfrm>
-            <a:off x="6720840" y="3154680"/>
-            <a:ext cx="2331720" cy="320040"/>
-          </a:xfrm>
-          <a:prstGeom prst="rect">
-            <a:avLst/>
-          </a:prstGeom>
-          <a:noFill/>
-          <a:ln/>
-        </p:spPr>
-        <p:txBody>
-          <a:bodyPr wrap="square" rtlCol="0" anchor="ctr"/>
-          <a:lstStyle/>
-          <a:p>
-            <a:pPr indent="0" marL="0">
-              <a:buNone/>
-            </a:pPr>
-            <a:r>
-              <a:rPr lang="en-US" sz="1300" b="1" dirty="0">
-                <a:solidFill>
-                  <a:srgbClr val="FFFFFF"/>
-                </a:solidFill>
-                <a:latin typeface="Arial" pitchFamily="34" charset="0"/>
-                <a:ea typeface="Arial" pitchFamily="34" charset="-122"/>
-                <a:cs typeface="Arial" pitchFamily="34" charset="-120"/>
-              </a:rPr>
-              <a:t>Near u128::MAX</a:t>
-            </a:r>
-            <a:endParaRPr lang="en-US" sz="1300" dirty="0"/>
-          </a:p>
-        </p:txBody>
-      </p:sp>
-      <p:sp>
-        <p:nvSpPr>
-          <p:cNvPr id="24" name="Text 22"/>
-          <p:cNvSpPr/>
-          <p:nvPr/>
-        </p:nvSpPr>
-        <p:spPr>
-          <a:xfrm>
-            <a:off x="6720840" y="3520440"/>
-            <a:ext cx="2331720" cy="548640"/>
-          </a:xfrm>
-          <a:prstGeom prst="rect">
-            <a:avLst/>
-          </a:prstGeom>
-          <a:noFill/>
-          <a:ln/>
-        </p:spPr>
-        <p:txBody>
-          <a:bodyPr wrap="square" rtlCol="0" anchor="ctr"/>
-          <a:lstStyle/>
-          <a:p>
-            <a:pPr indent="0" marL="0">
-              <a:buNone/>
-            </a:pPr>
-            <a:r>
-              <a:rPr lang="en-US" sz="1100" dirty="0">
-                <a:solidFill>
-                  <a:srgbClr val="A0AEC0"/>
-                </a:solidFill>
-                <a:latin typeface="Arial" pitchFamily="34" charset="0"/>
-                <a:ea typeface="Arial" pitchFamily="34" charset="-122"/>
-                <a:cs typeface="Arial" pitchFamily="34" charset="-120"/>
-              </a:rPr>
-              <a:t>Arithmetic overflow protection</a:t>
-            </a:r>
-            <a:endParaRPr lang="en-US" sz="1100" dirty="0"/>
-          </a:p>
-        </p:txBody>
-      </p:sp>
-      <p:sp>
-        <p:nvSpPr>
-          <p:cNvPr id="25" name="Shape 23"/>
-          <p:cNvSpPr/>
-          <p:nvPr/>
-        </p:nvSpPr>
-        <p:spPr>
-          <a:xfrm>
-            <a:off x="457200" y="5486400"/>
-            <a:ext cx="11247120" cy="777240"/>
-          </a:xfrm>
-          <a:prstGeom prst="rect">
-            <a:avLst/>
-          </a:prstGeom>
-          <a:solidFill>
-            <a:srgbClr val="1F2937"/>
+            <a:srgbClr val="111827"/>
           </a:solidFill>
           <a:ln w="12700">
             <a:solidFill>
@@ -5529,30 +4870,30 @@
       </p:sp>
       <p:sp>
         <p:nvSpPr>
-          <p:cNvPr id="26" name="Text 24"/>
-          <p:cNvSpPr/>
-          <p:nvPr/>
-        </p:nvSpPr>
-        <p:spPr>
-          <a:xfrm>
-            <a:off x="914400" y="5532120"/>
-            <a:ext cx="2560320" cy="365760"/>
-          </a:xfrm>
-          <a:prstGeom prst="rect">
-            <a:avLst/>
-          </a:prstGeom>
-          <a:noFill/>
-          <a:ln/>
-        </p:spPr>
-        <p:txBody>
-          <a:bodyPr wrap="square" rtlCol="0" anchor="ctr"/>
-          <a:lstStyle/>
-          <a:p>
-            <a:pPr indent="0" marL="0">
-              <a:buNone/>
-            </a:pPr>
-            <a:r>
-              <a:rPr lang="en-US" sz="1600" b="1" dirty="0">
+          <p:cNvPr id="6" name="Text 4"/>
+          <p:cNvSpPr/>
+          <p:nvPr/>
+        </p:nvSpPr>
+        <p:spPr>
+          <a:xfrm>
+            <a:off x="4069080" y="1188720"/>
+            <a:ext cx="3383280" cy="594360"/>
+          </a:xfrm>
+          <a:prstGeom prst="rect">
+            <a:avLst/>
+          </a:prstGeom>
+          <a:noFill/>
+          <a:ln/>
+        </p:spPr>
+        <p:txBody>
+          <a:bodyPr wrap="square" rtlCol="0" anchor="ctr"/>
+          <a:lstStyle/>
+          <a:p>
+            <a:pPr indent="0" marL="0">
+              <a:buNone/>
+            </a:pPr>
+            <a:r>
+              <a:rPr lang="en-US" sz="2800" b="1" dirty="0">
                 <a:solidFill>
                   <a:srgbClr val="00D4FF"/>
                 </a:solidFill>
@@ -5560,38 +4901,38 @@
                 <a:ea typeface="Arial" pitchFamily="34" charset="-122"/>
                 <a:cs typeface="Arial" pitchFamily="34" charset="-120"/>
               </a:rPr>
-              <a:t>5h 55min</a:t>
-            </a:r>
-            <a:endParaRPr lang="en-US" sz="1600" dirty="0"/>
-          </a:p>
-        </p:txBody>
-      </p:sp>
-      <p:sp>
-        <p:nvSpPr>
-          <p:cNvPr id="27" name="Text 25"/>
-          <p:cNvSpPr/>
-          <p:nvPr/>
-        </p:nvSpPr>
-        <p:spPr>
-          <a:xfrm>
-            <a:off x="914400" y="5897880"/>
-            <a:ext cx="2560320" cy="274320"/>
-          </a:xfrm>
-          <a:prstGeom prst="rect">
-            <a:avLst/>
-          </a:prstGeom>
-          <a:noFill/>
-          <a:ln/>
-        </p:spPr>
-        <p:txBody>
-          <a:bodyPr wrap="square" rtlCol="0" anchor="ctr"/>
-          <a:lstStyle/>
-          <a:p>
-            <a:pPr indent="0" marL="0">
-              <a:buNone/>
-            </a:pPr>
-            <a:r>
-              <a:rPr lang="en-US" sz="1100" dirty="0">
+              <a:t>122B+</a:t>
+            </a:r>
+            <a:endParaRPr lang="en-US" sz="2800" dirty="0"/>
+          </a:p>
+        </p:txBody>
+      </p:sp>
+      <p:sp>
+        <p:nvSpPr>
+          <p:cNvPr id="7" name="Text 5"/>
+          <p:cNvSpPr/>
+          <p:nvPr/>
+        </p:nvSpPr>
+        <p:spPr>
+          <a:xfrm>
+            <a:off x="4069080" y="1783080"/>
+            <a:ext cx="3383280" cy="685800"/>
+          </a:xfrm>
+          <a:prstGeom prst="rect">
+            <a:avLst/>
+          </a:prstGeom>
+          <a:noFill/>
+          <a:ln/>
+        </p:spPr>
+        <p:txBody>
+          <a:bodyPr wrap="square" rtlCol="0" anchor="ctr"/>
+          <a:lstStyle/>
+          <a:p>
+            <a:pPr indent="0" marL="0">
+              <a:buNone/>
+            </a:pPr>
+            <a:r>
+              <a:rPr lang="en-US" sz="1300" dirty="0">
                 <a:solidFill>
                   <a:srgbClr val="A0AEC0"/>
                 </a:solidFill>
@@ -5599,38 +4940,80 @@
                 <a:ea typeface="Arial" pitchFamily="34" charset="-122"/>
                 <a:cs typeface="Arial" pitchFamily="34" charset="-120"/>
               </a:rPr>
-              <a:t>CI Fuzz Duration</a:t>
-            </a:r>
-            <a:endParaRPr lang="en-US" sz="1100" dirty="0"/>
-          </a:p>
-        </p:txBody>
-      </p:sp>
-      <p:sp>
-        <p:nvSpPr>
-          <p:cNvPr id="28" name="Text 26"/>
-          <p:cNvSpPr/>
-          <p:nvPr/>
-        </p:nvSpPr>
-        <p:spPr>
-          <a:xfrm>
-            <a:off x="3657600" y="5532120"/>
-            <a:ext cx="2560320" cy="365760"/>
-          </a:xfrm>
-          <a:prstGeom prst="rect">
-            <a:avLst/>
-          </a:prstGeom>
-          <a:noFill/>
-          <a:ln/>
-        </p:spPr>
-        <p:txBody>
-          <a:bodyPr wrap="square" rtlCol="0" anchor="ctr"/>
-          <a:lstStyle/>
-          <a:p>
-            <a:pPr indent="0" marL="0">
-              <a:buNone/>
-            </a:pPr>
-            <a:r>
-              <a:rPr lang="en-US" sz="1600" b="1" dirty="0">
+              <a:t>Ops per single</a:t>
+            </a:r>
+            <a:endParaRPr lang="en-US" sz="1300" dirty="0"/>
+          </a:p>
+          <a:p>
+            <a:pPr indent="0" marL="0">
+              <a:buNone/>
+            </a:pPr>
+            <a:r>
+              <a:rPr lang="en-US" sz="1300" dirty="0">
+                <a:solidFill>
+                  <a:srgbClr val="A0AEC0"/>
+                </a:solidFill>
+                <a:latin typeface="Arial" pitchFamily="34" charset="0"/>
+                <a:ea typeface="Arial" pitchFamily="34" charset="-122"/>
+                <a:cs typeface="Arial" pitchFamily="34" charset="-120"/>
+              </a:rPr>
+              <a:t>5h 55min run</a:t>
+            </a:r>
+            <a:endParaRPr lang="en-US" sz="1300" dirty="0"/>
+          </a:p>
+        </p:txBody>
+      </p:sp>
+      <p:sp>
+        <p:nvSpPr>
+          <p:cNvPr id="8" name="Shape 6"/>
+          <p:cNvSpPr/>
+          <p:nvPr/>
+        </p:nvSpPr>
+        <p:spPr>
+          <a:xfrm>
+            <a:off x="7863840" y="1097280"/>
+            <a:ext cx="3657600" cy="1600200"/>
+          </a:xfrm>
+          <a:prstGeom prst="rect">
+            <a:avLst/>
+          </a:prstGeom>
+          <a:solidFill>
+            <a:srgbClr val="111827"/>
+          </a:solidFill>
+          <a:ln w="12700">
+            <a:solidFill>
+              <a:srgbClr val="1F2937"/>
+            </a:solidFill>
+            <a:prstDash val="solid"/>
+          </a:ln>
+        </p:spPr>
+      </p:sp>
+      <p:sp>
+        <p:nvSpPr>
+          <p:cNvPr id="9" name="Text 7"/>
+          <p:cNvSpPr/>
+          <p:nvPr/>
+        </p:nvSpPr>
+        <p:spPr>
+          <a:xfrm>
+            <a:off x="8001000" y="1188720"/>
+            <a:ext cx="3383280" cy="594360"/>
+          </a:xfrm>
+          <a:prstGeom prst="rect">
+            <a:avLst/>
+          </a:prstGeom>
+          <a:noFill/>
+          <a:ln/>
+        </p:spPr>
+        <p:txBody>
+          <a:bodyPr wrap="square" rtlCol="0" anchor="ctr"/>
+          <a:lstStyle/>
+          <a:p>
+            <a:pPr indent="0" marL="0">
+              <a:buNone/>
+            </a:pPr>
+            <a:r>
+              <a:rPr lang="en-US" sz="2800" b="1" dirty="0">
                 <a:solidFill>
                   <a:srgbClr val="00D4FF"/>
                 </a:solidFill>
@@ -5638,38 +5021,38 @@
                 <a:ea typeface="Arial" pitchFamily="34" charset="-122"/>
                 <a:cs typeface="Arial" pitchFamily="34" charset="-120"/>
               </a:rPr>
-              <a:t>5,750,000</a:t>
-            </a:r>
-            <a:endParaRPr lang="en-US" sz="1600" dirty="0"/>
-          </a:p>
-        </p:txBody>
-      </p:sp>
-      <p:sp>
-        <p:nvSpPr>
-          <p:cNvPr id="29" name="Text 27"/>
-          <p:cNvSpPr/>
-          <p:nvPr/>
-        </p:nvSpPr>
-        <p:spPr>
-          <a:xfrm>
-            <a:off x="3657600" y="5897880"/>
-            <a:ext cx="2560320" cy="274320"/>
-          </a:xfrm>
-          <a:prstGeom prst="rect">
-            <a:avLst/>
-          </a:prstGeom>
-          <a:noFill/>
-          <a:ln/>
-        </p:spPr>
-        <p:txBody>
-          <a:bodyPr wrap="square" rtlCol="0" anchor="ctr"/>
-          <a:lstStyle/>
-          <a:p>
-            <a:pPr indent="0" marL="0">
-              <a:buNone/>
-            </a:pPr>
-            <a:r>
-              <a:rPr lang="en-US" sz="1100" dirty="0">
+              <a:t>~5.75M</a:t>
+            </a:r>
+            <a:endParaRPr lang="en-US" sz="2800" dirty="0"/>
+          </a:p>
+        </p:txBody>
+      </p:sp>
+      <p:sp>
+        <p:nvSpPr>
+          <p:cNvPr id="10" name="Text 8"/>
+          <p:cNvSpPr/>
+          <p:nvPr/>
+        </p:nvSpPr>
+        <p:spPr>
+          <a:xfrm>
+            <a:off x="8001000" y="1783080"/>
+            <a:ext cx="3383280" cy="685800"/>
+          </a:xfrm>
+          <a:prstGeom prst="rect">
+            <a:avLst/>
+          </a:prstGeom>
+          <a:noFill/>
+          <a:ln/>
+        </p:spPr>
+        <p:txBody>
+          <a:bodyPr wrap="square" rtlCol="0" anchor="ctr"/>
+          <a:lstStyle/>
+          <a:p>
+            <a:pPr indent="0" marL="0">
+              <a:buNone/>
+            </a:pPr>
+            <a:r>
+              <a:rPr lang="en-US" sz="1300" dirty="0">
                 <a:solidFill>
                   <a:srgbClr val="A0AEC0"/>
                 </a:solidFill>
@@ -5677,38 +5060,80 @@
                 <a:ea typeface="Arial" pitchFamily="34" charset="-122"/>
                 <a:cs typeface="Arial" pitchFamily="34" charset="-120"/>
               </a:rPr>
-              <a:t>Ops/sec (GitHub Runner)</a:t>
-            </a:r>
-            <a:endParaRPr lang="en-US" sz="1100" dirty="0"/>
-          </a:p>
-        </p:txBody>
-      </p:sp>
-      <p:sp>
-        <p:nvSpPr>
-          <p:cNvPr id="30" name="Text 28"/>
-          <p:cNvSpPr/>
-          <p:nvPr/>
-        </p:nvSpPr>
-        <p:spPr>
-          <a:xfrm>
-            <a:off x="6400800" y="5532120"/>
-            <a:ext cx="2560320" cy="365760"/>
-          </a:xfrm>
-          <a:prstGeom prst="rect">
-            <a:avLst/>
-          </a:prstGeom>
-          <a:noFill/>
-          <a:ln/>
-        </p:spPr>
-        <p:txBody>
-          <a:bodyPr wrap="square" rtlCol="0" anchor="ctr"/>
-          <a:lstStyle/>
-          <a:p>
-            <a:pPr indent="0" marL="0">
-              <a:buNone/>
-            </a:pPr>
-            <a:r>
-              <a:rPr lang="en-US" sz="1600" b="1" dirty="0">
+              <a:t>Ops/sec on</a:t>
+            </a:r>
+            <a:endParaRPr lang="en-US" sz="1300" dirty="0"/>
+          </a:p>
+          <a:p>
+            <a:pPr indent="0" marL="0">
+              <a:buNone/>
+            </a:pPr>
+            <a:r>
+              <a:rPr lang="en-US" sz="1300" dirty="0">
+                <a:solidFill>
+                  <a:srgbClr val="A0AEC0"/>
+                </a:solidFill>
+                <a:latin typeface="Arial" pitchFamily="34" charset="0"/>
+                <a:ea typeface="Arial" pitchFamily="34" charset="-122"/>
+                <a:cs typeface="Arial" pitchFamily="34" charset="-120"/>
+              </a:rPr>
+              <a:t>GitHub CI runner</a:t>
+            </a:r>
+            <a:endParaRPr lang="en-US" sz="1300" dirty="0"/>
+          </a:p>
+        </p:txBody>
+      </p:sp>
+      <p:sp>
+        <p:nvSpPr>
+          <p:cNvPr id="11" name="Shape 9"/>
+          <p:cNvSpPr/>
+          <p:nvPr/>
+        </p:nvSpPr>
+        <p:spPr>
+          <a:xfrm>
+            <a:off x="3931920" y="2926080"/>
+            <a:ext cx="3657600" cy="1600200"/>
+          </a:xfrm>
+          <a:prstGeom prst="rect">
+            <a:avLst/>
+          </a:prstGeom>
+          <a:solidFill>
+            <a:srgbClr val="111827"/>
+          </a:solidFill>
+          <a:ln w="12700">
+            <a:solidFill>
+              <a:srgbClr val="1F2937"/>
+            </a:solidFill>
+            <a:prstDash val="solid"/>
+          </a:ln>
+        </p:spPr>
+      </p:sp>
+      <p:sp>
+        <p:nvSpPr>
+          <p:cNvPr id="12" name="Text 10"/>
+          <p:cNvSpPr/>
+          <p:nvPr/>
+        </p:nvSpPr>
+        <p:spPr>
+          <a:xfrm>
+            <a:off x="4069080" y="3017520"/>
+            <a:ext cx="3383280" cy="594360"/>
+          </a:xfrm>
+          <a:prstGeom prst="rect">
+            <a:avLst/>
+          </a:prstGeom>
+          <a:noFill/>
+          <a:ln/>
+        </p:spPr>
+        <p:txBody>
+          <a:bodyPr wrap="square" rtlCol="0" anchor="ctr"/>
+          <a:lstStyle/>
+          <a:p>
+            <a:pPr indent="0" marL="0">
+              <a:buNone/>
+            </a:pPr>
+            <a:r>
+              <a:rPr lang="en-US" sz="2800" b="1" dirty="0">
                 <a:solidFill>
                   <a:srgbClr val="00D4FF"/>
                 </a:solidFill>
@@ -5716,38 +5141,38 @@
                 <a:ea typeface="Arial" pitchFamily="34" charset="-122"/>
                 <a:cs typeface="Arial" pitchFamily="34" charset="-120"/>
               </a:rPr>
-              <a:t>&gt;10,000,000</a:t>
-            </a:r>
-            <a:endParaRPr lang="en-US" sz="1600" dirty="0"/>
-          </a:p>
-        </p:txBody>
-      </p:sp>
-      <p:sp>
-        <p:nvSpPr>
-          <p:cNvPr id="31" name="Text 29"/>
-          <p:cNvSpPr/>
-          <p:nvPr/>
-        </p:nvSpPr>
-        <p:spPr>
-          <a:xfrm>
-            <a:off x="6400800" y="5897880"/>
-            <a:ext cx="2560320" cy="274320"/>
-          </a:xfrm>
-          <a:prstGeom prst="rect">
-            <a:avLst/>
-          </a:prstGeom>
-          <a:noFill/>
-          <a:ln/>
-        </p:spPr>
-        <p:txBody>
-          <a:bodyPr wrap="square" rtlCol="0" anchor="ctr"/>
-          <a:lstStyle/>
-          <a:p>
-            <a:pPr indent="0" marL="0">
-              <a:buNone/>
-            </a:pPr>
-            <a:r>
-              <a:rPr lang="en-US" sz="1100" dirty="0">
+              <a:t>&gt;10M</a:t>
+            </a:r>
+            <a:endParaRPr lang="en-US" sz="2800" dirty="0"/>
+          </a:p>
+        </p:txBody>
+      </p:sp>
+      <p:sp>
+        <p:nvSpPr>
+          <p:cNvPr id="13" name="Text 11"/>
+          <p:cNvSpPr/>
+          <p:nvPr/>
+        </p:nvSpPr>
+        <p:spPr>
+          <a:xfrm>
+            <a:off x="4069080" y="3611880"/>
+            <a:ext cx="3383280" cy="685800"/>
+          </a:xfrm>
+          <a:prstGeom prst="rect">
+            <a:avLst/>
+          </a:prstGeom>
+          <a:noFill/>
+          <a:ln/>
+        </p:spPr>
+        <p:txBody>
+          <a:bodyPr wrap="square" rtlCol="0" anchor="ctr"/>
+          <a:lstStyle/>
+          <a:p>
+            <a:pPr indent="0" marL="0">
+              <a:buNone/>
+            </a:pPr>
+            <a:r>
+              <a:rPr lang="en-US" sz="1300" dirty="0">
                 <a:solidFill>
                   <a:srgbClr val="A0AEC0"/>
                 </a:solidFill>
@@ -5755,38 +5180,80 @@
                 <a:ea typeface="Arial" pitchFamily="34" charset="-122"/>
                 <a:cs typeface="Arial" pitchFamily="34" charset="-120"/>
               </a:rPr>
-              <a:t>Ops/sec (Apple M1/M4)</a:t>
-            </a:r>
-            <a:endParaRPr lang="en-US" sz="1100" dirty="0"/>
-          </a:p>
-        </p:txBody>
-      </p:sp>
-      <p:sp>
-        <p:nvSpPr>
-          <p:cNvPr id="32" name="Text 30"/>
-          <p:cNvSpPr/>
-          <p:nvPr/>
-        </p:nvSpPr>
-        <p:spPr>
-          <a:xfrm>
-            <a:off x="9144000" y="5532120"/>
-            <a:ext cx="2560320" cy="365760"/>
-          </a:xfrm>
-          <a:prstGeom prst="rect">
-            <a:avLst/>
-          </a:prstGeom>
-          <a:noFill/>
-          <a:ln/>
-        </p:spPr>
-        <p:txBody>
-          <a:bodyPr wrap="square" rtlCol="0" anchor="ctr"/>
-          <a:lstStyle/>
-          <a:p>
-            <a:pPr indent="0" marL="0">
-              <a:buNone/>
-            </a:pPr>
-            <a:r>
-              <a:rPr lang="en-US" sz="1600" b="1" dirty="0">
+              <a:t>Ops/sec on</a:t>
+            </a:r>
+            <a:endParaRPr lang="en-US" sz="1300" dirty="0"/>
+          </a:p>
+          <a:p>
+            <a:pPr indent="0" marL="0">
+              <a:buNone/>
+            </a:pPr>
+            <a:r>
+              <a:rPr lang="en-US" sz="1300" dirty="0">
+                <a:solidFill>
+                  <a:srgbClr val="A0AEC0"/>
+                </a:solidFill>
+                <a:latin typeface="Arial" pitchFamily="34" charset="0"/>
+                <a:ea typeface="Arial" pitchFamily="34" charset="-122"/>
+                <a:cs typeface="Arial" pitchFamily="34" charset="-120"/>
+              </a:rPr>
+              <a:t>Apple M1 / M4</a:t>
+            </a:r>
+            <a:endParaRPr lang="en-US" sz="1300" dirty="0"/>
+          </a:p>
+        </p:txBody>
+      </p:sp>
+      <p:sp>
+        <p:nvSpPr>
+          <p:cNvPr id="14" name="Shape 12"/>
+          <p:cNvSpPr/>
+          <p:nvPr/>
+        </p:nvSpPr>
+        <p:spPr>
+          <a:xfrm>
+            <a:off x="7863840" y="2926080"/>
+            <a:ext cx="3657600" cy="1600200"/>
+          </a:xfrm>
+          <a:prstGeom prst="rect">
+            <a:avLst/>
+          </a:prstGeom>
+          <a:solidFill>
+            <a:srgbClr val="111827"/>
+          </a:solidFill>
+          <a:ln w="12700">
+            <a:solidFill>
+              <a:srgbClr val="1F2937"/>
+            </a:solidFill>
+            <a:prstDash val="solid"/>
+          </a:ln>
+        </p:spPr>
+      </p:sp>
+      <p:sp>
+        <p:nvSpPr>
+          <p:cNvPr id="15" name="Text 13"/>
+          <p:cNvSpPr/>
+          <p:nvPr/>
+        </p:nvSpPr>
+        <p:spPr>
+          <a:xfrm>
+            <a:off x="8001000" y="3017520"/>
+            <a:ext cx="3383280" cy="594360"/>
+          </a:xfrm>
+          <a:prstGeom prst="rect">
+            <a:avLst/>
+          </a:prstGeom>
+          <a:noFill/>
+          <a:ln/>
+        </p:spPr>
+        <p:txBody>
+          <a:bodyPr wrap="square" rtlCol="0" anchor="ctr"/>
+          <a:lstStyle/>
+          <a:p>
+            <a:pPr indent="0" marL="0">
+              <a:buNone/>
+            </a:pPr>
+            <a:r>
+              <a:rPr lang="en-US" sz="2800" b="1" dirty="0">
                 <a:solidFill>
                   <a:srgbClr val="00D4FF"/>
                 </a:solidFill>
@@ -5794,38 +5261,38 @@
                 <a:ea typeface="Arial" pitchFamily="34" charset="-122"/>
                 <a:cs typeface="Arial" pitchFamily="34" charset="-120"/>
               </a:rPr>
-              <a:t>libFuzzer</a:t>
-            </a:r>
-            <a:endParaRPr lang="en-US" sz="1600" dirty="0"/>
-          </a:p>
-        </p:txBody>
-      </p:sp>
-      <p:sp>
-        <p:nvSpPr>
-          <p:cNvPr id="33" name="Text 31"/>
-          <p:cNvSpPr/>
-          <p:nvPr/>
-        </p:nvSpPr>
-        <p:spPr>
-          <a:xfrm>
-            <a:off x="9144000" y="5897880"/>
-            <a:ext cx="2560320" cy="274320"/>
-          </a:xfrm>
-          <a:prstGeom prst="rect">
-            <a:avLst/>
-          </a:prstGeom>
-          <a:noFill/>
-          <a:ln/>
-        </p:spPr>
-        <p:txBody>
-          <a:bodyPr wrap="square" rtlCol="0" anchor="ctr"/>
-          <a:lstStyle/>
-          <a:p>
-            <a:pPr indent="0" marL="0">
-              <a:buNone/>
-            </a:pPr>
-            <a:r>
-              <a:rPr lang="en-US" sz="1100" dirty="0">
+              <a:t>Daily</a:t>
+            </a:r>
+            <a:endParaRPr lang="en-US" sz="2800" dirty="0"/>
+          </a:p>
+        </p:txBody>
+      </p:sp>
+      <p:sp>
+        <p:nvSpPr>
+          <p:cNvPr id="16" name="Text 14"/>
+          <p:cNvSpPr/>
+          <p:nvPr/>
+        </p:nvSpPr>
+        <p:spPr>
+          <a:xfrm>
+            <a:off x="8001000" y="3611880"/>
+            <a:ext cx="3383280" cy="685800"/>
+          </a:xfrm>
+          <a:prstGeom prst="rect">
+            <a:avLst/>
+          </a:prstGeom>
+          <a:noFill/>
+          <a:ln/>
+        </p:spPr>
+        <p:txBody>
+          <a:bodyPr wrap="square" rtlCol="0" anchor="ctr"/>
+          <a:lstStyle/>
+          <a:p>
+            <a:pPr indent="0" marL="0">
+              <a:buNone/>
+            </a:pPr>
+            <a:r>
+              <a:rPr lang="en-US" sz="1300" dirty="0">
                 <a:solidFill>
                   <a:srgbClr val="A0AEC0"/>
                 </a:solidFill>
@@ -5833,9 +5300,168 @@
                 <a:ea typeface="Arial" pitchFamily="34" charset="-122"/>
                 <a:cs typeface="Arial" pitchFamily="34" charset="-120"/>
               </a:rPr>
-              <a:t>Harness</a:t>
-            </a:r>
-            <a:endParaRPr lang="en-US" sz="1100" dirty="0"/>
+              <a:t>Automated CI</a:t>
+            </a:r>
+            <a:endParaRPr lang="en-US" sz="1300" dirty="0"/>
+          </a:p>
+          <a:p>
+            <a:pPr indent="0" marL="0">
+              <a:buNone/>
+            </a:pPr>
+            <a:r>
+              <a:rPr lang="en-US" sz="1300" dirty="0">
+                <a:solidFill>
+                  <a:srgbClr val="A0AEC0"/>
+                </a:solidFill>
+                <a:latin typeface="Arial" pitchFamily="34" charset="0"/>
+                <a:ea typeface="Arial" pitchFamily="34" charset="-122"/>
+                <a:cs typeface="Arial" pitchFamily="34" charset="-120"/>
+              </a:rPr>
+              <a:t>schedule: 03:00 UTC</a:t>
+            </a:r>
+            <a:endParaRPr lang="en-US" sz="1300" dirty="0"/>
+          </a:p>
+        </p:txBody>
+      </p:sp>
+      <p:sp>
+        <p:nvSpPr>
+          <p:cNvPr id="17" name="Shape 15"/>
+          <p:cNvSpPr/>
+          <p:nvPr/>
+        </p:nvSpPr>
+        <p:spPr>
+          <a:xfrm>
+            <a:off x="457200" y="4846320"/>
+            <a:ext cx="11247120" cy="868680"/>
+          </a:xfrm>
+          <a:prstGeom prst="rect">
+            <a:avLst/>
+          </a:prstGeom>
+          <a:solidFill>
+            <a:srgbClr val="1F2937"/>
+          </a:solidFill>
+          <a:ln w="12700">
+            <a:solidFill>
+              <a:srgbClr val="10B981"/>
+            </a:solidFill>
+            <a:prstDash val="solid"/>
+          </a:ln>
+        </p:spPr>
+      </p:sp>
+      <p:sp>
+        <p:nvSpPr>
+          <p:cNvPr id="18" name="Text 16"/>
+          <p:cNvSpPr/>
+          <p:nvPr/>
+        </p:nvSpPr>
+        <p:spPr>
+          <a:xfrm>
+            <a:off x="640080" y="4937760"/>
+            <a:ext cx="10881360" cy="640080"/>
+          </a:xfrm>
+          <a:prstGeom prst="rect">
+            <a:avLst/>
+          </a:prstGeom>
+          <a:noFill/>
+          <a:ln/>
+        </p:spPr>
+        <p:txBody>
+          <a:bodyPr wrap="square" rtlCol="0" anchor="ctr"/>
+          <a:lstStyle/>
+          <a:p>
+            <a:pPr indent="0" marL="0">
+              <a:buNone/>
+            </a:pPr>
+            <a:r>
+              <a:rPr lang="en-US" sz="1500" b="1" dirty="0">
+                <a:solidFill>
+                  <a:srgbClr val="10B981"/>
+                </a:solidFill>
+                <a:latin typeface="Arial" pitchFamily="34" charset="0"/>
+                <a:ea typeface="Arial" pitchFamily="34" charset="-122"/>
+                <a:cs typeface="Arial" pitchFamily="34" charset="-120"/>
+              </a:rPr>
+              <a:t>🔥  Cumulative across multiple parallel CI runs: ops in the trillions. Zero crashes. Zero violations.</a:t>
+            </a:r>
+            <a:endParaRPr lang="en-US" sz="1500" dirty="0"/>
+          </a:p>
+        </p:txBody>
+      </p:sp>
+      <p:sp>
+        <p:nvSpPr>
+          <p:cNvPr id="19" name="Text 17"/>
+          <p:cNvSpPr/>
+          <p:nvPr/>
+        </p:nvSpPr>
+        <p:spPr>
+          <a:xfrm>
+            <a:off x="457200" y="5897880"/>
+            <a:ext cx="4572000" cy="320040"/>
+          </a:xfrm>
+          <a:prstGeom prst="rect">
+            <a:avLst/>
+          </a:prstGeom>
+          <a:noFill/>
+          <a:ln/>
+        </p:spPr>
+        <p:txBody>
+          <a:bodyPr wrap="square" rtlCol="0" anchor="ctr"/>
+          <a:lstStyle/>
+          <a:p>
+            <a:pPr indent="0" marL="0">
+              <a:buNone/>
+            </a:pPr>
+            <a:r>
+              <a:rPr lang="en-US" sz="1300" dirty="0">
+                <a:solidFill>
+                  <a:srgbClr val="A0AEC0"/>
+                </a:solidFill>
+                <a:latin typeface="Arial" pitchFamily="34" charset="0"/>
+                <a:ea typeface="Arial" pitchFamily="34" charset="-122"/>
+                <a:cs typeface="Arial" pitchFamily="34" charset="-120"/>
+              </a:rPr>
+              <a:t>Stratified fuzz harness — 5 modes:</a:t>
+            </a:r>
+            <a:endParaRPr lang="en-US" sz="1300" dirty="0"/>
+          </a:p>
+        </p:txBody>
+      </p:sp>
+      <p:sp>
+        <p:nvSpPr>
+          <p:cNvPr id="20" name="Text 18"/>
+          <p:cNvSpPr/>
+          <p:nvPr/>
+        </p:nvSpPr>
+        <p:spPr>
+          <a:xfrm>
+            <a:off x="5029200" y="5897880"/>
+            <a:ext cx="6675120" cy="320040"/>
+          </a:xfrm>
+          <a:prstGeom prst="rect">
+            <a:avLst/>
+          </a:prstGeom>
+          <a:noFill/>
+          <a:ln/>
+        </p:spPr>
+        <p:txBody>
+          <a:bodyPr wrap="square" rtlCol="0" anchor="ctr"/>
+          <a:lstStyle/>
+          <a:p>
+            <a:pPr indent="0" marL="0">
+              <a:buNone/>
+            </a:pPr>
+            <a:r>
+              <a:rPr lang="en-US" sz="1300" dirty="0">
+                <a:solidFill>
+                  <a:srgbClr val="00D4FF"/>
+                </a:solidFill>
+                <a:latin typeface="Arial" pitchFamily="34" charset="0"/>
+                <a:ea typeface="Arial" pitchFamily="34" charset="-122"/>
+                <a:cs typeface="Arial" pitchFamily="34" charset="-120"/>
+              </a:rPr>
+              <a:t>NEG_E boundary · Large p / Dust · Negative field · p=0 edge · Near u128::MAX</a:t>
+            </a:r>
+            <a:endParaRPr lang="en-US" sz="1300" dirty="0"/>
           </a:p>
         </p:txBody>
       </p:sp>
@@ -5879,7 +5505,7 @@
         </p:nvSpPr>
         <p:spPr>
           <a:xfrm>
-            <a:off x="457200" y="365760"/>
+            <a:off x="457200" y="320040"/>
             <a:ext cx="11247120" cy="640080"/>
           </a:xfrm>
           <a:prstGeom prst="rect">
@@ -5918,8 +5544,8 @@
         </p:nvSpPr>
         <p:spPr>
           <a:xfrm>
-            <a:off x="457200" y="1188720"/>
-            <a:ext cx="5303520" cy="4389120"/>
+            <a:off x="457200" y="1097280"/>
+            <a:ext cx="5394960" cy="4572000"/>
           </a:xfrm>
           <a:prstGeom prst="rect">
             <a:avLst/>
@@ -5927,7 +5553,7 @@
           <a:solidFill>
             <a:srgbClr val="111827"/>
           </a:solidFill>
-          <a:ln w="25400">
+          <a:ln w="12700">
             <a:solidFill>
               <a:srgbClr val="00D4FF"/>
             </a:solidFill>
@@ -5943,7 +5569,7 @@
         </p:nvSpPr>
         <p:spPr>
           <a:xfrm>
-            <a:off x="594360" y="1325880"/>
+            <a:off x="640080" y="1234440"/>
             <a:ext cx="5029200" cy="411480"/>
           </a:xfrm>
           <a:prstGeom prst="rect">
@@ -5982,7 +5608,7 @@
         </p:nvSpPr>
         <p:spPr>
           <a:xfrm>
-            <a:off x="594360" y="1737360"/>
+            <a:off x="640080" y="1691640"/>
             <a:ext cx="5029200" cy="320040"/>
           </a:xfrm>
           <a:prstGeom prst="rect">
@@ -6021,7 +5647,7 @@
         </p:nvSpPr>
         <p:spPr>
           <a:xfrm>
-            <a:off x="594360" y="2148840"/>
+            <a:off x="640080" y="2103120"/>
             <a:ext cx="5029200" cy="384048"/>
           </a:xfrm>
           <a:prstGeom prst="rect">
@@ -6060,7 +5686,7 @@
         </p:nvSpPr>
         <p:spPr>
           <a:xfrm>
-            <a:off x="594360" y="2587752"/>
+            <a:off x="640080" y="2542032"/>
             <a:ext cx="5029200" cy="384048"/>
           </a:xfrm>
           <a:prstGeom prst="rect">
@@ -6099,7 +5725,7 @@
         </p:nvSpPr>
         <p:spPr>
           <a:xfrm>
-            <a:off x="594360" y="3026664"/>
+            <a:off x="640080" y="2980944"/>
             <a:ext cx="5029200" cy="384048"/>
           </a:xfrm>
           <a:prstGeom prst="rect">
@@ -6138,7 +5764,7 @@
         </p:nvSpPr>
         <p:spPr>
           <a:xfrm>
-            <a:off x="594360" y="3465576"/>
+            <a:off x="640080" y="3419856"/>
             <a:ext cx="5029200" cy="384048"/>
           </a:xfrm>
           <a:prstGeom prst="rect">
@@ -6177,7 +5803,7 @@
         </p:nvSpPr>
         <p:spPr>
           <a:xfrm>
-            <a:off x="594360" y="3904488"/>
+            <a:off x="640080" y="3858768"/>
             <a:ext cx="5029200" cy="384048"/>
           </a:xfrm>
           <a:prstGeom prst="rect">
@@ -6216,7 +5842,7 @@
         </p:nvSpPr>
         <p:spPr>
           <a:xfrm>
-            <a:off x="594360" y="4343400"/>
+            <a:off x="640080" y="4297680"/>
             <a:ext cx="5029200" cy="384048"/>
           </a:xfrm>
           <a:prstGeom prst="rect">
@@ -6255,7 +5881,7 @@
         </p:nvSpPr>
         <p:spPr>
           <a:xfrm>
-            <a:off x="594360" y="4782312"/>
+            <a:off x="640080" y="4736592"/>
             <a:ext cx="5029200" cy="384048"/>
           </a:xfrm>
           <a:prstGeom prst="rect">
@@ -6294,7 +5920,7 @@
         </p:nvSpPr>
         <p:spPr>
           <a:xfrm>
-            <a:off x="5897880" y="2926080"/>
+            <a:off x="5989320" y="3017520"/>
             <a:ext cx="822960" cy="822960"/>
           </a:xfrm>
           <a:prstGeom prst="rect">
@@ -6350,8 +5976,8 @@
         </p:nvSpPr>
         <p:spPr>
           <a:xfrm>
-            <a:off x="6858000" y="1188720"/>
-            <a:ext cx="4846320" cy="4389120"/>
+            <a:off x="6400800" y="1097280"/>
+            <a:ext cx="5394960" cy="4572000"/>
           </a:xfrm>
           <a:prstGeom prst="rect">
             <a:avLst/>
@@ -6359,7 +5985,7 @@
           <a:solidFill>
             <a:srgbClr val="111827"/>
           </a:solidFill>
-          <a:ln w="25400">
+          <a:ln w="12700">
             <a:solidFill>
               <a:srgbClr val="7C3AED"/>
             </a:solidFill>
@@ -6375,8 +6001,8 @@
         </p:nvSpPr>
         <p:spPr>
           <a:xfrm>
-            <a:off x="6995160" y="1325880"/>
-            <a:ext cx="4572000" cy="411480"/>
+            <a:off x="6583680" y="1234440"/>
+            <a:ext cx="5029200" cy="411480"/>
           </a:xfrm>
           <a:prstGeom prst="rect">
             <a:avLst/>
@@ -6414,8 +6040,8 @@
         </p:nvSpPr>
         <p:spPr>
           <a:xfrm>
-            <a:off x="6995160" y="1737360"/>
-            <a:ext cx="4572000" cy="320040"/>
+            <a:off x="6583680" y="1691640"/>
+            <a:ext cx="5029200" cy="320040"/>
           </a:xfrm>
           <a:prstGeom prst="rect">
             <a:avLst/>
@@ -6453,8 +6079,8 @@
         </p:nvSpPr>
         <p:spPr>
           <a:xfrm>
-            <a:off x="6995160" y="2148840"/>
-            <a:ext cx="4572000" cy="384048"/>
+            <a:off x="6583680" y="2103120"/>
+            <a:ext cx="5029200" cy="384048"/>
           </a:xfrm>
           <a:prstGeom prst="rect">
             <a:avLst/>
@@ -6492,8 +6118,8 @@
         </p:nvSpPr>
         <p:spPr>
           <a:xfrm>
-            <a:off x="6995160" y="2587752"/>
-            <a:ext cx="4572000" cy="384048"/>
+            <a:off x="6583680" y="2542032"/>
+            <a:ext cx="5029200" cy="384048"/>
           </a:xfrm>
           <a:prstGeom prst="rect">
             <a:avLst/>
@@ -6531,8 +6157,8 @@
         </p:nvSpPr>
         <p:spPr>
           <a:xfrm>
-            <a:off x="6995160" y="3026664"/>
-            <a:ext cx="4572000" cy="384048"/>
+            <a:off x="6583680" y="2980944"/>
+            <a:ext cx="5029200" cy="384048"/>
           </a:xfrm>
           <a:prstGeom prst="rect">
             <a:avLst/>
@@ -6570,8 +6196,8 @@
         </p:nvSpPr>
         <p:spPr>
           <a:xfrm>
-            <a:off x="6995160" y="3465576"/>
-            <a:ext cx="4572000" cy="384048"/>
+            <a:off x="6583680" y="3419856"/>
+            <a:ext cx="5029200" cy="384048"/>
           </a:xfrm>
           <a:prstGeom prst="rect">
             <a:avLst/>
@@ -6595,7 +6221,7 @@
                 <a:ea typeface="Arial" pitchFamily="34" charset="-122"/>
                 <a:cs typeface="Arial" pitchFamily="34" charset="-120"/>
               </a:rPr>
-              <a:t>✅  Fee anti-griefing guard</a:t>
+              <a:t>✅  Fee anti-griefing guard (F-04 fixed)</a:t>
             </a:r>
             <a:endParaRPr lang="en-US" sz="1300" dirty="0"/>
           </a:p>
@@ -6609,8 +6235,8 @@
         </p:nvSpPr>
         <p:spPr>
           <a:xfrm>
-            <a:off x="6995160" y="3904488"/>
-            <a:ext cx="4572000" cy="384048"/>
+            <a:off x="6583680" y="3858768"/>
+            <a:ext cx="5029200" cy="384048"/>
           </a:xfrm>
           <a:prstGeom prst="rect">
             <a:avLst/>
@@ -6648,8 +6274,8 @@
         </p:nvSpPr>
         <p:spPr>
           <a:xfrm>
-            <a:off x="6995160" y="4343400"/>
-            <a:ext cx="4572000" cy="384048"/>
+            <a:off x="6583680" y="4297680"/>
+            <a:ext cx="5029200" cy="384048"/>
           </a:xfrm>
           <a:prstGeom prst="rect">
             <a:avLst/>
@@ -6687,8 +6313,8 @@
         </p:nvSpPr>
         <p:spPr>
           <a:xfrm>
-            <a:off x="6995160" y="4782312"/>
-            <a:ext cx="4572000" cy="384048"/>
+            <a:off x="6583680" y="4736592"/>
+            <a:ext cx="5029200" cy="384048"/>
           </a:xfrm>
           <a:prstGeom prst="rect">
             <a:avLst/>
@@ -6758,7 +6384,7 @@
         </p:nvSpPr>
         <p:spPr>
           <a:xfrm>
-            <a:off x="457200" y="365760"/>
+            <a:off x="457200" y="320040"/>
             <a:ext cx="11247120" cy="640080"/>
           </a:xfrm>
           <a:prstGeom prst="rect">
@@ -6814,6 +6440,45 @@
         <p:spPr>
           <a:xfrm>
             <a:off x="7589520" y="1280160"/>
+            <a:ext cx="4297680" cy="685800"/>
+          </a:xfrm>
+          <a:prstGeom prst="rect">
+            <a:avLst/>
+          </a:prstGeom>
+          <a:noFill/>
+          <a:ln/>
+        </p:spPr>
+        <p:txBody>
+          <a:bodyPr wrap="square" rtlCol="0" anchor="ctr"/>
+          <a:lstStyle/>
+          <a:p>
+            <a:pPr indent="0" marL="0">
+              <a:buNone/>
+            </a:pPr>
+            <a:r>
+              <a:rPr lang="en-US" sz="3600" b="1" dirty="0">
+                <a:solidFill>
+                  <a:srgbClr val="00D4FF"/>
+                </a:solidFill>
+                <a:latin typeface="Arial" pitchFamily="34" charset="0"/>
+                <a:ea typeface="Arial" pitchFamily="34" charset="-122"/>
+                <a:cs typeface="Arial" pitchFamily="34" charset="-120"/>
+              </a:rPr>
+              <a:t>122B+</a:t>
+            </a:r>
+            <a:endParaRPr lang="en-US" sz="3600" dirty="0"/>
+          </a:p>
+        </p:txBody>
+      </p:sp>
+      <p:sp>
+        <p:nvSpPr>
+          <p:cNvPr id="5" name="Text 2"/>
+          <p:cNvSpPr/>
+          <p:nvPr/>
+        </p:nvSpPr>
+        <p:spPr>
+          <a:xfrm>
+            <a:off x="7589520" y="1965960"/>
             <a:ext cx="4297680" cy="640080"/>
           </a:xfrm>
           <a:prstGeom prst="rect">
@@ -6830,46 +6495,7 @@
               <a:buNone/>
             </a:pPr>
             <a:r>
-              <a:rPr lang="en-US" sz="4000" b="1" dirty="0">
-                <a:solidFill>
-                  <a:srgbClr val="00D4FF"/>
-                </a:solidFill>
-                <a:latin typeface="Arial" pitchFamily="34" charset="0"/>
-                <a:ea typeface="Arial" pitchFamily="34" charset="-122"/>
-                <a:cs typeface="Arial" pitchFamily="34" charset="-120"/>
-              </a:rPr>
-              <a:t>~5.75M</a:t>
-            </a:r>
-            <a:endParaRPr lang="en-US" sz="4000" dirty="0"/>
-          </a:p>
-        </p:txBody>
-      </p:sp>
-      <p:sp>
-        <p:nvSpPr>
-          <p:cNvPr id="5" name="Text 2"/>
-          <p:cNvSpPr/>
-          <p:nvPr/>
-        </p:nvSpPr>
-        <p:spPr>
-          <a:xfrm>
-            <a:off x="7589520" y="1920240"/>
-            <a:ext cx="4297680" cy="594360"/>
-          </a:xfrm>
-          <a:prstGeom prst="rect">
-            <a:avLst/>
-          </a:prstGeom>
-          <a:noFill/>
-          <a:ln/>
-        </p:spPr>
-        <p:txBody>
-          <a:bodyPr wrap="square" rtlCol="0" anchor="ctr"/>
-          <a:lstStyle/>
-          <a:p>
-            <a:pPr indent="0" marL="0">
-              <a:buNone/>
-            </a:pPr>
-            <a:r>
-              <a:rPr lang="en-US" sz="1400" dirty="0">
+              <a:rPr lang="en-US" sz="1300" dirty="0">
                 <a:solidFill>
                   <a:srgbClr val="A0AEC0"/>
                 </a:solidFill>
@@ -6877,16 +6503,111 @@
                 <a:ea typeface="Arial" pitchFamily="34" charset="-122"/>
                 <a:cs typeface="Arial" pitchFamily="34" charset="-120"/>
               </a:rPr>
+              <a:t>ops per single run</a:t>
+            </a:r>
+            <a:endParaRPr lang="en-US" sz="1300" dirty="0"/>
+          </a:p>
+          <a:p>
+            <a:pPr indent="0" marL="0">
+              <a:buNone/>
+            </a:pPr>
+            <a:r>
+              <a:rPr lang="en-US" sz="1300" dirty="0">
+                <a:solidFill>
+                  <a:srgbClr val="A0AEC0"/>
+                </a:solidFill>
+                <a:latin typeface="Arial" pitchFamily="34" charset="0"/>
+                <a:ea typeface="Arial" pitchFamily="34" charset="-122"/>
+                <a:cs typeface="Arial" pitchFamily="34" charset="-120"/>
+              </a:rPr>
+              <a:t>(5h 55min, GitHub CI)</a:t>
+            </a:r>
+            <a:endParaRPr lang="en-US" sz="1300" dirty="0"/>
+          </a:p>
+        </p:txBody>
+      </p:sp>
+      <p:sp>
+        <p:nvSpPr>
+          <p:cNvPr id="6" name="Text 3"/>
+          <p:cNvSpPr/>
+          <p:nvPr/>
+        </p:nvSpPr>
+        <p:spPr>
+          <a:xfrm>
+            <a:off x="7589520" y="2880360"/>
+            <a:ext cx="4297680" cy="685800"/>
+          </a:xfrm>
+          <a:prstGeom prst="rect">
+            <a:avLst/>
+          </a:prstGeom>
+          <a:noFill/>
+          <a:ln/>
+        </p:spPr>
+        <p:txBody>
+          <a:bodyPr wrap="square" rtlCol="0" anchor="ctr"/>
+          <a:lstStyle/>
+          <a:p>
+            <a:pPr indent="0" marL="0">
+              <a:buNone/>
+            </a:pPr>
+            <a:r>
+              <a:rPr lang="en-US" sz="3600" b="1" dirty="0">
+                <a:solidFill>
+                  <a:srgbClr val="10B981"/>
+                </a:solidFill>
+                <a:latin typeface="Arial" pitchFamily="34" charset="0"/>
+                <a:ea typeface="Arial" pitchFamily="34" charset="-122"/>
+                <a:cs typeface="Arial" pitchFamily="34" charset="-120"/>
+              </a:rPr>
+              <a:t>&gt;10M</a:t>
+            </a:r>
+            <a:endParaRPr lang="en-US" sz="3600" dirty="0"/>
+          </a:p>
+        </p:txBody>
+      </p:sp>
+      <p:sp>
+        <p:nvSpPr>
+          <p:cNvPr id="7" name="Text 4"/>
+          <p:cNvSpPr/>
+          <p:nvPr/>
+        </p:nvSpPr>
+        <p:spPr>
+          <a:xfrm>
+            <a:off x="7589520" y="3566160"/>
+            <a:ext cx="4297680" cy="640080"/>
+          </a:xfrm>
+          <a:prstGeom prst="rect">
+            <a:avLst/>
+          </a:prstGeom>
+          <a:noFill/>
+          <a:ln/>
+        </p:spPr>
+        <p:txBody>
+          <a:bodyPr wrap="square" rtlCol="0" anchor="ctr"/>
+          <a:lstStyle/>
+          <a:p>
+            <a:pPr indent="0" marL="0">
+              <a:buNone/>
+            </a:pPr>
+            <a:r>
+              <a:rPr lang="en-US" sz="1300" dirty="0">
+                <a:solidFill>
+                  <a:srgbClr val="A0AEC0"/>
+                </a:solidFill>
+                <a:latin typeface="Arial" pitchFamily="34" charset="0"/>
+                <a:ea typeface="Arial" pitchFamily="34" charset="-122"/>
+                <a:cs typeface="Arial" pitchFamily="34" charset="-120"/>
+              </a:rPr>
               <a:t>ops/sec</a:t>
             </a:r>
-            <a:endParaRPr lang="en-US" sz="1400" dirty="0"/>
-          </a:p>
-          <a:p>
-            <a:pPr indent="0" marL="0">
-              <a:buNone/>
-            </a:pPr>
-            <a:r>
-              <a:rPr lang="en-US" sz="1400" dirty="0">
+            <a:endParaRPr lang="en-US" sz="1300" dirty="0"/>
+          </a:p>
+          <a:p>
+            <a:pPr indent="0" marL="0">
+              <a:buNone/>
+            </a:pPr>
+            <a:r>
+              <a:rPr lang="en-US" sz="1300" dirty="0">
                 <a:solidFill>
                   <a:srgbClr val="A0AEC0"/>
                 </a:solidFill>
@@ -6894,21 +6615,60 @@
                 <a:ea typeface="Arial" pitchFamily="34" charset="-122"/>
                 <a:cs typeface="Arial" pitchFamily="34" charset="-120"/>
               </a:rPr>
-              <a:t>GitHub CI (2 threads)</a:t>
-            </a:r>
-            <a:endParaRPr lang="en-US" sz="1400" dirty="0"/>
-          </a:p>
-        </p:txBody>
-      </p:sp>
-      <p:sp>
-        <p:nvSpPr>
-          <p:cNvPr id="6" name="Text 3"/>
-          <p:cNvSpPr/>
-          <p:nvPr/>
-        </p:nvSpPr>
-        <p:spPr>
-          <a:xfrm>
-            <a:off x="7589520" y="2834640"/>
+              <a:t>Apple M1 / M4</a:t>
+            </a:r>
+            <a:endParaRPr lang="en-US" sz="1300" dirty="0"/>
+          </a:p>
+        </p:txBody>
+      </p:sp>
+      <p:sp>
+        <p:nvSpPr>
+          <p:cNvPr id="8" name="Text 5"/>
+          <p:cNvSpPr/>
+          <p:nvPr/>
+        </p:nvSpPr>
+        <p:spPr>
+          <a:xfrm>
+            <a:off x="7589520" y="4480560"/>
+            <a:ext cx="4297680" cy="685800"/>
+          </a:xfrm>
+          <a:prstGeom prst="rect">
+            <a:avLst/>
+          </a:prstGeom>
+          <a:noFill/>
+          <a:ln/>
+        </p:spPr>
+        <p:txBody>
+          <a:bodyPr wrap="square" rtlCol="0" anchor="ctr"/>
+          <a:lstStyle/>
+          <a:p>
+            <a:pPr indent="0" marL="0">
+              <a:buNone/>
+            </a:pPr>
+            <a:r>
+              <a:rPr lang="en-US" sz="3600" b="1" dirty="0">
+                <a:solidFill>
+                  <a:srgbClr val="7C3AED"/>
+                </a:solidFill>
+                <a:latin typeface="Arial" pitchFamily="34" charset="0"/>
+                <a:ea typeface="Arial" pitchFamily="34" charset="-122"/>
+                <a:cs typeface="Arial" pitchFamily="34" charset="-120"/>
+              </a:rPr>
+              <a:t>Trillions</a:t>
+            </a:r>
+            <a:endParaRPr lang="en-US" sz="3600" dirty="0"/>
+          </a:p>
+        </p:txBody>
+      </p:sp>
+      <p:sp>
+        <p:nvSpPr>
+          <p:cNvPr id="9" name="Text 6"/>
+          <p:cNvSpPr/>
+          <p:nvPr/>
+        </p:nvSpPr>
+        <p:spPr>
+          <a:xfrm>
+            <a:off x="7589520" y="5166360"/>
             <a:ext cx="4297680" cy="640080"/>
           </a:xfrm>
           <a:prstGeom prst="rect">
@@ -6925,46 +6685,7 @@
               <a:buNone/>
             </a:pPr>
             <a:r>
-              <a:rPr lang="en-US" sz="4000" b="1" dirty="0">
-                <a:solidFill>
-                  <a:srgbClr val="10B981"/>
-                </a:solidFill>
-                <a:latin typeface="Arial" pitchFamily="34" charset="0"/>
-                <a:ea typeface="Arial" pitchFamily="34" charset="-122"/>
-                <a:cs typeface="Arial" pitchFamily="34" charset="-120"/>
-              </a:rPr>
-              <a:t>&gt;10M</a:t>
-            </a:r>
-            <a:endParaRPr lang="en-US" sz="4000" dirty="0"/>
-          </a:p>
-        </p:txBody>
-      </p:sp>
-      <p:sp>
-        <p:nvSpPr>
-          <p:cNvPr id="7" name="Text 4"/>
-          <p:cNvSpPr/>
-          <p:nvPr/>
-        </p:nvSpPr>
-        <p:spPr>
-          <a:xfrm>
-            <a:off x="7589520" y="3474720"/>
-            <a:ext cx="4297680" cy="594360"/>
-          </a:xfrm>
-          <a:prstGeom prst="rect">
-            <a:avLst/>
-          </a:prstGeom>
-          <a:noFill/>
-          <a:ln/>
-        </p:spPr>
-        <p:txBody>
-          <a:bodyPr wrap="square" rtlCol="0" anchor="ctr"/>
-          <a:lstStyle/>
-          <a:p>
-            <a:pPr indent="0" marL="0">
-              <a:buNone/>
-            </a:pPr>
-            <a:r>
-              <a:rPr lang="en-US" sz="1400" dirty="0">
+              <a:rPr lang="en-US" sz="1300" dirty="0">
                 <a:solidFill>
                   <a:srgbClr val="A0AEC0"/>
                 </a:solidFill>
@@ -6972,16 +6693,16 @@
                 <a:ea typeface="Arial" pitchFamily="34" charset="-122"/>
                 <a:cs typeface="Arial" pitchFamily="34" charset="-120"/>
               </a:rPr>
-              <a:t>ops/sec</a:t>
-            </a:r>
-            <a:endParaRPr lang="en-US" sz="1400" dirty="0"/>
-          </a:p>
-          <a:p>
-            <a:pPr indent="0" marL="0">
-              <a:buNone/>
-            </a:pPr>
-            <a:r>
-              <a:rPr lang="en-US" sz="1400" dirty="0">
+              <a:t>cumulative across</a:t>
+            </a:r>
+            <a:endParaRPr lang="en-US" sz="1300" dirty="0"/>
+          </a:p>
+          <a:p>
+            <a:pPr indent="0" marL="0">
+              <a:buNone/>
+            </a:pPr>
+            <a:r>
+              <a:rPr lang="en-US" sz="1300" dirty="0">
                 <a:solidFill>
                   <a:srgbClr val="A0AEC0"/>
                 </a:solidFill>
@@ -6989,104 +6710,9 @@
                 <a:ea typeface="Arial" pitchFamily="34" charset="-122"/>
                 <a:cs typeface="Arial" pitchFamily="34" charset="-120"/>
               </a:rPr>
-              <a:t>Apple M1 / M4</a:t>
-            </a:r>
-            <a:endParaRPr lang="en-US" sz="1400" dirty="0"/>
-          </a:p>
-        </p:txBody>
-      </p:sp>
-      <p:sp>
-        <p:nvSpPr>
-          <p:cNvPr id="8" name="Text 5"/>
-          <p:cNvSpPr/>
-          <p:nvPr/>
-        </p:nvSpPr>
-        <p:spPr>
-          <a:xfrm>
-            <a:off x="7589520" y="4389120"/>
-            <a:ext cx="4297680" cy="640080"/>
-          </a:xfrm>
-          <a:prstGeom prst="rect">
-            <a:avLst/>
-          </a:prstGeom>
-          <a:noFill/>
-          <a:ln/>
-        </p:spPr>
-        <p:txBody>
-          <a:bodyPr wrap="square" rtlCol="0" anchor="ctr"/>
-          <a:lstStyle/>
-          <a:p>
-            <a:pPr indent="0" marL="0">
-              <a:buNone/>
-            </a:pPr>
-            <a:r>
-              <a:rPr lang="en-US" sz="4000" b="1" dirty="0">
-                <a:solidFill>
-                  <a:srgbClr val="7C3AED"/>
-                </a:solidFill>
-                <a:latin typeface="Arial" pitchFamily="34" charset="0"/>
-                <a:ea typeface="Arial" pitchFamily="34" charset="-122"/>
-                <a:cs typeface="Arial" pitchFamily="34" charset="-120"/>
-              </a:rPr>
-              <a:t>256M+</a:t>
-            </a:r>
-            <a:endParaRPr lang="en-US" sz="4000" dirty="0"/>
-          </a:p>
-        </p:txBody>
-      </p:sp>
-      <p:sp>
-        <p:nvSpPr>
-          <p:cNvPr id="9" name="Text 6"/>
-          <p:cNvSpPr/>
-          <p:nvPr/>
-        </p:nvSpPr>
-        <p:spPr>
-          <a:xfrm>
-            <a:off x="7589520" y="5029200"/>
-            <a:ext cx="4297680" cy="594360"/>
-          </a:xfrm>
-          <a:prstGeom prst="rect">
-            <a:avLst/>
-          </a:prstGeom>
-          <a:noFill/>
-          <a:ln/>
-        </p:spPr>
-        <p:txBody>
-          <a:bodyPr wrap="square" rtlCol="0" anchor="ctr"/>
-          <a:lstStyle/>
-          <a:p>
-            <a:pPr indent="0" marL="0">
-              <a:buNone/>
-            </a:pPr>
-            <a:r>
-              <a:rPr lang="en-US" sz="1400" dirty="0">
-                <a:solidFill>
-                  <a:srgbClr val="A0AEC0"/>
-                </a:solidFill>
-                <a:latin typeface="Arial" pitchFamily="34" charset="0"/>
-                <a:ea typeface="Arial" pitchFamily="34" charset="-122"/>
-                <a:cs typeface="Arial" pitchFamily="34" charset="-120"/>
-              </a:rPr>
-              <a:t>total ops</a:t>
-            </a:r>
-            <a:endParaRPr lang="en-US" sz="1400" dirty="0"/>
-          </a:p>
-          <a:p>
-            <a:pPr indent="0" marL="0">
-              <a:buNone/>
-            </a:pPr>
-            <a:r>
-              <a:rPr lang="en-US" sz="1400" dirty="0">
-                <a:solidFill>
-                  <a:srgbClr val="A0AEC0"/>
-                </a:solidFill>
-                <a:latin typeface="Arial" pitchFamily="34" charset="0"/>
-                <a:ea typeface="Arial" pitchFamily="34" charset="-122"/>
-                <a:cs typeface="Arial" pitchFamily="34" charset="-120"/>
-              </a:rPr>
-              <a:t>in 5h 55min</a:t>
-            </a:r>
-            <a:endParaRPr lang="en-US" sz="1400" dirty="0"/>
+              <a:t>all CI runs to date</a:t>
+            </a:r>
+            <a:endParaRPr lang="en-US" sz="1300" dirty="0"/>
           </a:p>
         </p:txBody>
       </p:sp>
@@ -7123,7 +6749,7 @@
                 <a:ea typeface="Arial" pitchFamily="34" charset="-122"/>
                 <a:cs typeface="Arial" pitchFamily="34" charset="-120"/>
               </a:rPr>
-              <a:t>⚠  Core operation benchmarks. Full network stack measured separately when p2p layer is live.</a:t>
+              <a:t>⚠  Core benchmarks. Full network TPS measured when p2p layer is live.</a:t>
             </a:r>
             <a:endParaRPr lang="en-US" sz="1100" dirty="0"/>
           </a:p>
@@ -7169,7 +6795,7 @@
         </p:nvSpPr>
         <p:spPr>
           <a:xfrm>
-            <a:off x="457200" y="365760"/>
+            <a:off x="457200" y="320040"/>
             <a:ext cx="11247120" cy="640080"/>
           </a:xfrm>
           <a:prstGeom prst="rect">
@@ -7208,8 +6834,8 @@
         </p:nvSpPr>
         <p:spPr>
           <a:xfrm>
-            <a:off x="457200" y="1188720"/>
-            <a:ext cx="5303520" cy="4572000"/>
+            <a:off x="457200" y="1097280"/>
+            <a:ext cx="5394960" cy="4754880"/>
           </a:xfrm>
           <a:prstGeom prst="rect">
             <a:avLst/>
@@ -7233,7 +6859,7 @@
         </p:nvSpPr>
         <p:spPr>
           <a:xfrm>
-            <a:off x="594360" y="1325880"/>
+            <a:off x="640080" y="1234440"/>
             <a:ext cx="5029200" cy="411480"/>
           </a:xfrm>
           <a:prstGeom prst="rect">
@@ -7272,7 +6898,7 @@
         </p:nvSpPr>
         <p:spPr>
           <a:xfrm>
-            <a:off x="594360" y="1828800"/>
+            <a:off x="640080" y="1783080"/>
             <a:ext cx="5029200" cy="384048"/>
           </a:xfrm>
           <a:prstGeom prst="rect">
@@ -7311,7 +6937,7 @@
         </p:nvSpPr>
         <p:spPr>
           <a:xfrm>
-            <a:off x="594360" y="2267712"/>
+            <a:off x="640080" y="2212848"/>
             <a:ext cx="5029200" cy="384048"/>
           </a:xfrm>
           <a:prstGeom prst="rect">
@@ -7350,7 +6976,7 @@
         </p:nvSpPr>
         <p:spPr>
           <a:xfrm>
-            <a:off x="594360" y="2706624"/>
+            <a:off x="640080" y="2642616"/>
             <a:ext cx="5029200" cy="384048"/>
           </a:xfrm>
           <a:prstGeom prst="rect">
@@ -7389,7 +7015,7 @@
         </p:nvSpPr>
         <p:spPr>
           <a:xfrm>
-            <a:off x="594360" y="3145536"/>
+            <a:off x="640080" y="3072384"/>
             <a:ext cx="5029200" cy="384048"/>
           </a:xfrm>
           <a:prstGeom prst="rect">
@@ -7428,7 +7054,7 @@
         </p:nvSpPr>
         <p:spPr>
           <a:xfrm>
-            <a:off x="594360" y="3584448"/>
+            <a:off x="640080" y="3502152"/>
             <a:ext cx="5029200" cy="384048"/>
           </a:xfrm>
           <a:prstGeom prst="rect">
@@ -7467,7 +7093,7 @@
         </p:nvSpPr>
         <p:spPr>
           <a:xfrm>
-            <a:off x="594360" y="4023360"/>
+            <a:off x="640080" y="3931920"/>
             <a:ext cx="5029200" cy="384048"/>
           </a:xfrm>
           <a:prstGeom prst="rect">
@@ -7506,7 +7132,7 @@
         </p:nvSpPr>
         <p:spPr>
           <a:xfrm>
-            <a:off x="594360" y="4462272"/>
+            <a:off x="640080" y="4361688"/>
             <a:ext cx="5029200" cy="384048"/>
           </a:xfrm>
           <a:prstGeom prst="rect">
@@ -7531,7 +7157,7 @@
                 <a:ea typeface="Arial" pitchFamily="34" charset="-122"/>
                 <a:cs typeface="Arial" pitchFamily="34" charset="-120"/>
               </a:rPr>
-              <a:t>• libFuzzer harness — 256M+ ops, 0 violations</a:t>
+              <a:t>• Stratified libFuzzer harness — 5 modes</a:t>
             </a:r>
             <a:endParaRPr lang="en-US" sz="1300" dirty="0"/>
           </a:p>
@@ -7545,7 +7171,7 @@
         </p:nvSpPr>
         <p:spPr>
           <a:xfrm>
-            <a:off x="594360" y="4901184"/>
+            <a:off x="640080" y="4791456"/>
             <a:ext cx="5029200" cy="384048"/>
           </a:xfrm>
           <a:prstGeom prst="rect">
@@ -7570,7 +7196,7 @@
                 <a:ea typeface="Arial" pitchFamily="34" charset="-122"/>
                 <a:cs typeface="Arial" pitchFamily="34" charset="-120"/>
               </a:rPr>
-              <a:t>• GitHub CI — lint, test, fuzz on every commit</a:t>
+              <a:t>• 122B+ ops per run, 0 violations</a:t>
             </a:r>
             <a:endParaRPr lang="en-US" sz="1300" dirty="0"/>
           </a:p>
@@ -7584,7 +7210,7 @@
         </p:nvSpPr>
         <p:spPr>
           <a:xfrm>
-            <a:off x="594360" y="5340096"/>
+            <a:off x="640080" y="5221224"/>
             <a:ext cx="5029200" cy="384048"/>
           </a:xfrm>
           <a:prstGeom prst="rect">
@@ -7609,6 +7235,45 @@
                 <a:ea typeface="Arial" pitchFamily="34" charset="-122"/>
                 <a:cs typeface="Arial" pitchFamily="34" charset="-120"/>
               </a:rPr>
+              <a:t>• Daily CI at 03:00 UTC — auto fuzz</a:t>
+            </a:r>
+            <a:endParaRPr lang="en-US" sz="1300" dirty="0"/>
+          </a:p>
+        </p:txBody>
+      </p:sp>
+      <p:sp>
+        <p:nvSpPr>
+          <p:cNvPr id="14" name="Text 12"/>
+          <p:cNvSpPr/>
+          <p:nvPr/>
+        </p:nvSpPr>
+        <p:spPr>
+          <a:xfrm>
+            <a:off x="640080" y="5650992"/>
+            <a:ext cx="5029200" cy="384048"/>
+          </a:xfrm>
+          <a:prstGeom prst="rect">
+            <a:avLst/>
+          </a:prstGeom>
+          <a:noFill/>
+          <a:ln/>
+        </p:spPr>
+        <p:txBody>
+          <a:bodyPr wrap="square" rtlCol="0" anchor="ctr"/>
+          <a:lstStyle/>
+          <a:p>
+            <a:pPr indent="0" marL="0">
+              <a:buNone/>
+            </a:pPr>
+            <a:r>
+              <a:rPr lang="en-US" sz="1300" dirty="0">
+                <a:solidFill>
+                  <a:srgbClr val="FFFFFF"/>
+                </a:solidFill>
+                <a:latin typeface="Arial" pitchFamily="34" charset="0"/>
+                <a:ea typeface="Arial" pitchFamily="34" charset="-122"/>
+                <a:cs typeface="Arial" pitchFamily="34" charset="-120"/>
+              </a:rPr>
               <a:t>• Apache 2.0 license with patent protection</a:t>
             </a:r>
             <a:endParaRPr lang="en-US" sz="1300" dirty="0"/>
@@ -7617,14 +7282,14 @@
       </p:sp>
       <p:sp>
         <p:nvSpPr>
-          <p:cNvPr id="14" name="Shape 12"/>
-          <p:cNvSpPr/>
-          <p:nvPr/>
-        </p:nvSpPr>
-        <p:spPr>
-          <a:xfrm>
-            <a:off x="6400800" y="1188720"/>
-            <a:ext cx="5303520" cy="4572000"/>
+          <p:cNvPr id="15" name="Shape 13"/>
+          <p:cNvSpPr/>
+          <p:nvPr/>
+        </p:nvSpPr>
+        <p:spPr>
+          <a:xfrm>
+            <a:off x="6400800" y="1097280"/>
+            <a:ext cx="5394960" cy="4754880"/>
           </a:xfrm>
           <a:prstGeom prst="rect">
             <a:avLst/>
@@ -7642,13 +7307,13 @@
       </p:sp>
       <p:sp>
         <p:nvSpPr>
-          <p:cNvPr id="15" name="Text 13"/>
-          <p:cNvSpPr/>
-          <p:nvPr/>
-        </p:nvSpPr>
-        <p:spPr>
-          <a:xfrm>
-            <a:off x="6537960" y="1325880"/>
+          <p:cNvPr id="16" name="Text 14"/>
+          <p:cNvSpPr/>
+          <p:nvPr/>
+        </p:nvSpPr>
+        <p:spPr>
+          <a:xfrm>
+            <a:off x="6583680" y="1234440"/>
             <a:ext cx="5029200" cy="411480"/>
           </a:xfrm>
           <a:prstGeom prst="rect">
@@ -7681,13 +7346,13 @@
       </p:sp>
       <p:sp>
         <p:nvSpPr>
-          <p:cNvPr id="16" name="Text 14"/>
-          <p:cNvSpPr/>
-          <p:nvPr/>
-        </p:nvSpPr>
-        <p:spPr>
-          <a:xfrm>
-            <a:off x="6537960" y="1828800"/>
+          <p:cNvPr id="17" name="Text 15"/>
+          <p:cNvSpPr/>
+          <p:nvPr/>
+        </p:nvSpPr>
+        <p:spPr>
+          <a:xfrm>
+            <a:off x="6583680" y="1783080"/>
             <a:ext cx="5029200" cy="429768"/>
           </a:xfrm>
           <a:prstGeom prst="rect">
@@ -7720,13 +7385,13 @@
       </p:sp>
       <p:sp>
         <p:nvSpPr>
-          <p:cNvPr id="17" name="Text 15"/>
-          <p:cNvSpPr/>
-          <p:nvPr/>
-        </p:nvSpPr>
-        <p:spPr>
-          <a:xfrm>
-            <a:off x="6537960" y="2313432"/>
+          <p:cNvPr id="18" name="Text 16"/>
+          <p:cNvSpPr/>
+          <p:nvPr/>
+        </p:nvSpPr>
+        <p:spPr>
+          <a:xfrm>
+            <a:off x="6583680" y="2267712"/>
             <a:ext cx="5029200" cy="429768"/>
           </a:xfrm>
           <a:prstGeom prst="rect">
@@ -7759,13 +7424,13 @@
       </p:sp>
       <p:sp>
         <p:nvSpPr>
-          <p:cNvPr id="18" name="Text 16"/>
-          <p:cNvSpPr/>
-          <p:nvPr/>
-        </p:nvSpPr>
-        <p:spPr>
-          <a:xfrm>
-            <a:off x="6537960" y="2798064"/>
+          <p:cNvPr id="19" name="Text 17"/>
+          <p:cNvSpPr/>
+          <p:nvPr/>
+        </p:nvSpPr>
+        <p:spPr>
+          <a:xfrm>
+            <a:off x="6583680" y="2752344"/>
             <a:ext cx="5029200" cy="429768"/>
           </a:xfrm>
           <a:prstGeom prst="rect">
@@ -7798,13 +7463,13 @@
       </p:sp>
       <p:sp>
         <p:nvSpPr>
-          <p:cNvPr id="19" name="Text 17"/>
-          <p:cNvSpPr/>
-          <p:nvPr/>
-        </p:nvSpPr>
-        <p:spPr>
-          <a:xfrm>
-            <a:off x="6537960" y="3282696"/>
+          <p:cNvPr id="20" name="Text 18"/>
+          <p:cNvSpPr/>
+          <p:nvPr/>
+        </p:nvSpPr>
+        <p:spPr>
+          <a:xfrm>
+            <a:off x="6583680" y="3236976"/>
             <a:ext cx="5029200" cy="429768"/>
           </a:xfrm>
           <a:prstGeom prst="rect">
@@ -7837,13 +7502,13 @@
       </p:sp>
       <p:sp>
         <p:nvSpPr>
-          <p:cNvPr id="20" name="Text 18"/>
-          <p:cNvSpPr/>
-          <p:nvPr/>
-        </p:nvSpPr>
-        <p:spPr>
-          <a:xfrm>
-            <a:off x="6537960" y="3767328"/>
+          <p:cNvPr id="21" name="Text 19"/>
+          <p:cNvSpPr/>
+          <p:nvPr/>
+        </p:nvSpPr>
+        <p:spPr>
+          <a:xfrm>
+            <a:off x="6583680" y="3721608"/>
             <a:ext cx="5029200" cy="429768"/>
           </a:xfrm>
           <a:prstGeom prst="rect">
@@ -7876,13 +7541,13 @@
       </p:sp>
       <p:sp>
         <p:nvSpPr>
-          <p:cNvPr id="21" name="Text 19"/>
-          <p:cNvSpPr/>
-          <p:nvPr/>
-        </p:nvSpPr>
-        <p:spPr>
-          <a:xfrm>
-            <a:off x="6537960" y="4251960"/>
+          <p:cNvPr id="22" name="Text 20"/>
+          <p:cNvSpPr/>
+          <p:nvPr/>
+        </p:nvSpPr>
+        <p:spPr>
+          <a:xfrm>
+            <a:off x="6583680" y="4206240"/>
             <a:ext cx="5029200" cy="429768"/>
           </a:xfrm>
           <a:prstGeom prst="rect">
@@ -7915,13 +7580,13 @@
       </p:sp>
       <p:sp>
         <p:nvSpPr>
-          <p:cNvPr id="22" name="Text 20"/>
-          <p:cNvSpPr/>
-          <p:nvPr/>
-        </p:nvSpPr>
-        <p:spPr>
-          <a:xfrm>
-            <a:off x="6537960" y="4736592"/>
+          <p:cNvPr id="23" name="Text 21"/>
+          <p:cNvSpPr/>
+          <p:nvPr/>
+        </p:nvSpPr>
+        <p:spPr>
+          <a:xfrm>
+            <a:off x="6583680" y="4690872"/>
             <a:ext cx="5029200" cy="429768"/>
           </a:xfrm>
           <a:prstGeom prst="rect">
@@ -7954,13 +7619,13 @@
       </p:sp>
       <p:sp>
         <p:nvSpPr>
-          <p:cNvPr id="23" name="Text 21"/>
-          <p:cNvSpPr/>
-          <p:nvPr/>
-        </p:nvSpPr>
-        <p:spPr>
-          <a:xfrm>
-            <a:off x="6537960" y="5221224"/>
+          <p:cNvPr id="24" name="Text 22"/>
+          <p:cNvSpPr/>
+          <p:nvPr/>
+        </p:nvSpPr>
+        <p:spPr>
+          <a:xfrm>
+            <a:off x="6583680" y="5175504"/>
             <a:ext cx="5029200" cy="429768"/>
           </a:xfrm>
           <a:prstGeom prst="rect">
@@ -7985,7 +7650,46 @@
                 <a:ea typeface="Arial" pitchFamily="34" charset="-122"/>
                 <a:cs typeface="Arial" pitchFamily="34" charset="-120"/>
               </a:rPr>
-              <a:t>• Developer SDK</a:t>
+              <a:t>• Developer SDK &amp; tooling</a:t>
+            </a:r>
+            <a:endParaRPr lang="en-US" sz="1300" dirty="0"/>
+          </a:p>
+        </p:txBody>
+      </p:sp>
+      <p:sp>
+        <p:nvSpPr>
+          <p:cNvPr id="25" name="Text 23"/>
+          <p:cNvSpPr/>
+          <p:nvPr/>
+        </p:nvSpPr>
+        <p:spPr>
+          <a:xfrm>
+            <a:off x="6583680" y="5660136"/>
+            <a:ext cx="5029200" cy="429768"/>
+          </a:xfrm>
+          <a:prstGeom prst="rect">
+            <a:avLst/>
+          </a:prstGeom>
+          <a:noFill/>
+          <a:ln/>
+        </p:spPr>
+        <p:txBody>
+          <a:bodyPr wrap="square" rtlCol="0" anchor="ctr"/>
+          <a:lstStyle/>
+          <a:p>
+            <a:pPr indent="0" marL="0">
+              <a:buNone/>
+            </a:pPr>
+            <a:r>
+              <a:rPr lang="en-US" sz="1300" dirty="0">
+                <a:solidFill>
+                  <a:srgbClr val="FFFFFF"/>
+                </a:solidFill>
+                <a:latin typeface="Arial" pitchFamily="34" charset="0"/>
+                <a:ea typeface="Arial" pitchFamily="34" charset="-122"/>
+                <a:cs typeface="Arial" pitchFamily="34" charset="-120"/>
+              </a:rPr>
+              <a:t>• Governance (multisig gate)</a:t>
             </a:r>
             <a:endParaRPr lang="en-US" sz="1300" dirty="0"/>
           </a:p>
@@ -8031,8 +7735,8 @@
         </p:nvSpPr>
         <p:spPr>
           <a:xfrm>
-            <a:off x="2743200" y="457200"/>
-            <a:ext cx="6675120" cy="6675120"/>
+            <a:off x="2926080" y="365760"/>
+            <a:ext cx="6400800" cy="6400800"/>
           </a:xfrm>
           <a:prstGeom prst="ellipse">
             <a:avLst/>
@@ -8058,8 +7762,8 @@
         </p:nvSpPr>
         <p:spPr>
           <a:xfrm>
-            <a:off x="4114800" y="731520"/>
-            <a:ext cx="3931920" cy="1371600"/>
+            <a:off x="4251960" y="640080"/>
+            <a:ext cx="3657600" cy="1463040"/>
           </a:xfrm>
           <a:prstGeom prst="rect">
             <a:avLst/>
@@ -8077,8 +7781,11 @@
             <a:r>
               <a:rPr lang="en-US" sz="7200" dirty="0">
                 <a:solidFill>
-                  <a:srgbClr val="000000"/>
-                </a:solidFill>
+                  <a:srgbClr val="FFFFFF"/>
+                </a:solidFill>
+                <a:latin typeface="Arial" pitchFamily="34" charset="0"/>
+                <a:ea typeface="Arial" pitchFamily="34" charset="-122"/>
+                <a:cs typeface="Arial" pitchFamily="34" charset="-120"/>
               </a:rPr>
               <a:t>⚡</a:t>
             </a:r>
@@ -8094,8 +7801,8 @@
         </p:nvSpPr>
         <p:spPr>
           <a:xfrm>
-            <a:off x="457200" y="2011680"/>
-            <a:ext cx="11247120" cy="731520"/>
+            <a:off x="457200" y="1920240"/>
+            <a:ext cx="11247120" cy="777240"/>
           </a:xfrm>
           <a:prstGeom prst="rect">
             <a:avLst/>
@@ -8133,7 +7840,7 @@
         </p:nvSpPr>
         <p:spPr>
           <a:xfrm>
-            <a:off x="457200" y="2834640"/>
+            <a:off x="457200" y="2788920"/>
             <a:ext cx="11247120" cy="457200"/>
           </a:xfrm>
           <a:prstGeom prst="rect">
@@ -8172,8 +7879,8 @@
         </p:nvSpPr>
         <p:spPr>
           <a:xfrm>
-            <a:off x="1371600" y="3520440"/>
-            <a:ext cx="9418320" cy="777240"/>
+            <a:off x="1371600" y="3429000"/>
+            <a:ext cx="9418320" cy="822960"/>
           </a:xfrm>
           <a:prstGeom prst="rect">
             <a:avLst/>
@@ -8228,7 +7935,7 @@
         </p:nvSpPr>
         <p:spPr>
           <a:xfrm>
-            <a:off x="2286000" y="4526280"/>
+            <a:off x="2286000" y="4480560"/>
             <a:ext cx="7589520" cy="731520"/>
           </a:xfrm>
           <a:prstGeom prst="rect">
@@ -8253,7 +7960,7 @@
         </p:nvSpPr>
         <p:spPr>
           <a:xfrm>
-            <a:off x="2286000" y="4572000"/>
+            <a:off x="2286000" y="4526280"/>
             <a:ext cx="7589520" cy="640080"/>
           </a:xfrm>
           <a:prstGeom prst="rect">
@@ -8292,7 +7999,7 @@
         </p:nvSpPr>
         <p:spPr>
           <a:xfrm>
-            <a:off x="457200" y="6217920"/>
+            <a:off x="457200" y="6263640"/>
             <a:ext cx="11247120" cy="320040"/>
           </a:xfrm>
           <a:prstGeom prst="rect">

</xml_diff>